<commit_message>
Update master deck PPTX
Co-Authored-By: Claude Sonnet 4.6 <noreply@anthropic.com>
</commit_message>
<xml_diff>
--- a/master-deck/MBC_MASTER_DECK.pptx
+++ b/master-deck/MBC_MASTER_DECK.pptx
@@ -2,17 +2,21 @@
 <file path=ppt/presentation.xml><?xml version="1.0" encoding="utf-8"?>
 <p:presentation xmlns:a="http://schemas.openxmlformats.org/drawingml/2006/main" xmlns:r="http://schemas.openxmlformats.org/officeDocument/2006/relationships" xmlns:p="http://schemas.openxmlformats.org/presentationml/2006/main" saveSubsetFonts="1" autoCompressPictures="0">
   <p:sldMasterIdLst>
-    <p:sldMasterId id="2147483650" r:id="rId1"/>
+    <p:sldMasterId id="2147483652" r:id="rId1"/>
   </p:sldMasterIdLst>
   <p:notesMasterIdLst>
-    <p:notesMasterId r:id="rId7"/>
+    <p:notesMasterId r:id="rId11"/>
   </p:notesMasterIdLst>
   <p:sldIdLst>
-    <p:sldId id="269" r:id="rId2"/>
+    <p:sldId id="274" r:id="rId2"/>
     <p:sldId id="263" r:id="rId3"/>
-    <p:sldId id="264" r:id="rId4"/>
-    <p:sldId id="265" r:id="rId5"/>
-    <p:sldId id="266" r:id="rId6"/>
+    <p:sldId id="270" r:id="rId4"/>
+    <p:sldId id="264" r:id="rId5"/>
+    <p:sldId id="272" r:id="rId6"/>
+    <p:sldId id="271" r:id="rId7"/>
+    <p:sldId id="265" r:id="rId8"/>
+    <p:sldId id="273" r:id="rId9"/>
+    <p:sldId id="266" r:id="rId10"/>
   </p:sldIdLst>
   <p:sldSz cx="9144000" cy="5143500" type="screen16x9"/>
   <p:notesSz cx="5143500" cy="9144000"/>
@@ -661,6 +665,342 @@
 </p:notes>
 </file>
 
+<file path=ppt/notesSlides/notesSlide6.xml><?xml version="1.0" encoding="utf-8"?>
+<p:notes xmlns:a="http://schemas.openxmlformats.org/drawingml/2006/main" xmlns:r="http://schemas.openxmlformats.org/officeDocument/2006/relationships" xmlns:p="http://schemas.openxmlformats.org/presentationml/2006/main">
+  <p:cSld>
+    <p:spTree>
+      <p:nvGrpSpPr>
+        <p:cNvPr id="1" name=""/>
+        <p:cNvGrpSpPr/>
+        <p:nvPr/>
+      </p:nvGrpSpPr>
+      <p:grpSpPr>
+        <a:xfrm>
+          <a:off x="0" y="0"/>
+          <a:ext cx="0" cy="0"/>
+          <a:chOff x="0" y="0"/>
+          <a:chExt cx="0" cy="0"/>
+        </a:xfrm>
+      </p:grpSpPr>
+      <p:sp>
+        <p:nvSpPr>
+          <p:cNvPr id="2" name="Slide Image Placeholder 1"/>
+          <p:cNvSpPr>
+            <a:spLocks noGrp="1" noRot="1" noChangeAspect="1"/>
+          </p:cNvSpPr>
+          <p:nvPr>
+            <p:ph type="sldImg"/>
+          </p:nvPr>
+        </p:nvSpPr>
+        <p:spPr/>
+      </p:sp>
+      <p:sp>
+        <p:nvSpPr>
+          <p:cNvPr id="3" name="Notes Placeholder 2"/>
+          <p:cNvSpPr>
+            <a:spLocks noGrp="1"/>
+          </p:cNvSpPr>
+          <p:nvPr>
+            <p:ph type="body" idx="1"/>
+          </p:nvPr>
+        </p:nvSpPr>
+        <p:spPr/>
+        <p:txBody>
+          <a:bodyPr/>
+          <a:lstStyle/>
+          <a:p>
+            <a:endParaRPr lang="en-US" dirty="0"/>
+          </a:p>
+        </p:txBody>
+      </p:sp>
+      <p:sp>
+        <p:nvSpPr>
+          <p:cNvPr id="4" name="Slide Number Placeholder 3"/>
+          <p:cNvSpPr>
+            <a:spLocks noGrp="1"/>
+          </p:cNvSpPr>
+          <p:nvPr>
+            <p:ph type="sldNum" sz="quarter" idx="10"/>
+          </p:nvPr>
+        </p:nvSpPr>
+        <p:spPr/>
+        <p:txBody>
+          <a:bodyPr/>
+          <a:lstStyle/>
+          <a:p>
+            <a:fld id="{F7021451-1387-4CA6-816F-3879F97B5CBC}" type="slidenum">
+              <a:rPr lang="en-US"/>
+              <a:t>6</a:t>
+            </a:fld>
+            <a:endParaRPr lang="en-US"/>
+          </a:p>
+        </p:txBody>
+      </p:sp>
+    </p:spTree>
+    <p:extLst>
+      <p:ext uri="{BB962C8B-B14F-4D97-AF65-F5344CB8AC3E}">
+        <p14:creationId xmlns:p14="http://schemas.microsoft.com/office/powerpoint/2010/main" val="1024086991"/>
+      </p:ext>
+    </p:extLst>
+  </p:cSld>
+  <p:clrMapOvr>
+    <a:masterClrMapping/>
+  </p:clrMapOvr>
+</p:notes>
+</file>
+
+<file path=ppt/notesSlides/notesSlide7.xml><?xml version="1.0" encoding="utf-8"?>
+<p:notes xmlns:a="http://schemas.openxmlformats.org/drawingml/2006/main" xmlns:r="http://schemas.openxmlformats.org/officeDocument/2006/relationships" xmlns:p="http://schemas.openxmlformats.org/presentationml/2006/main">
+  <p:cSld>
+    <p:spTree>
+      <p:nvGrpSpPr>
+        <p:cNvPr id="1" name=""/>
+        <p:cNvGrpSpPr/>
+        <p:nvPr/>
+      </p:nvGrpSpPr>
+      <p:grpSpPr>
+        <a:xfrm>
+          <a:off x="0" y="0"/>
+          <a:ext cx="0" cy="0"/>
+          <a:chOff x="0" y="0"/>
+          <a:chExt cx="0" cy="0"/>
+        </a:xfrm>
+      </p:grpSpPr>
+      <p:sp>
+        <p:nvSpPr>
+          <p:cNvPr id="2" name="Slide Image Placeholder 1"/>
+          <p:cNvSpPr>
+            <a:spLocks noGrp="1" noRot="1" noChangeAspect="1"/>
+          </p:cNvSpPr>
+          <p:nvPr>
+            <p:ph type="sldImg"/>
+          </p:nvPr>
+        </p:nvSpPr>
+        <p:spPr/>
+      </p:sp>
+      <p:sp>
+        <p:nvSpPr>
+          <p:cNvPr id="3" name="Notes Placeholder 2"/>
+          <p:cNvSpPr>
+            <a:spLocks noGrp="1"/>
+          </p:cNvSpPr>
+          <p:nvPr>
+            <p:ph type="body" idx="1"/>
+          </p:nvPr>
+        </p:nvSpPr>
+        <p:spPr/>
+        <p:txBody>
+          <a:bodyPr/>
+          <a:lstStyle/>
+          <a:p>
+            <a:endParaRPr lang="en-US" dirty="0"/>
+          </a:p>
+        </p:txBody>
+      </p:sp>
+      <p:sp>
+        <p:nvSpPr>
+          <p:cNvPr id="4" name="Slide Number Placeholder 3"/>
+          <p:cNvSpPr>
+            <a:spLocks noGrp="1"/>
+          </p:cNvSpPr>
+          <p:nvPr>
+            <p:ph type="sldNum" sz="quarter" idx="10"/>
+          </p:nvPr>
+        </p:nvSpPr>
+        <p:spPr/>
+        <p:txBody>
+          <a:bodyPr/>
+          <a:lstStyle/>
+          <a:p>
+            <a:fld id="{F7021451-1387-4CA6-816F-3879F97B5CBC}" type="slidenum">
+              <a:rPr lang="en-US"/>
+              <a:t>7</a:t>
+            </a:fld>
+            <a:endParaRPr lang="en-US"/>
+          </a:p>
+        </p:txBody>
+      </p:sp>
+    </p:spTree>
+    <p:extLst>
+      <p:ext uri="{BB962C8B-B14F-4D97-AF65-F5344CB8AC3E}">
+        <p14:creationId xmlns:p14="http://schemas.microsoft.com/office/powerpoint/2010/main" val="1024086991"/>
+      </p:ext>
+    </p:extLst>
+  </p:cSld>
+  <p:clrMapOvr>
+    <a:masterClrMapping/>
+  </p:clrMapOvr>
+</p:notes>
+</file>
+
+<file path=ppt/notesSlides/notesSlide8.xml><?xml version="1.0" encoding="utf-8"?>
+<p:notes xmlns:a="http://schemas.openxmlformats.org/drawingml/2006/main" xmlns:r="http://schemas.openxmlformats.org/officeDocument/2006/relationships" xmlns:p="http://schemas.openxmlformats.org/presentationml/2006/main">
+  <p:cSld>
+    <p:spTree>
+      <p:nvGrpSpPr>
+        <p:cNvPr id="1" name=""/>
+        <p:cNvGrpSpPr/>
+        <p:nvPr/>
+      </p:nvGrpSpPr>
+      <p:grpSpPr>
+        <a:xfrm>
+          <a:off x="0" y="0"/>
+          <a:ext cx="0" cy="0"/>
+          <a:chOff x="0" y="0"/>
+          <a:chExt cx="0" cy="0"/>
+        </a:xfrm>
+      </p:grpSpPr>
+      <p:sp>
+        <p:nvSpPr>
+          <p:cNvPr id="2" name="Slide Image Placeholder 1"/>
+          <p:cNvSpPr>
+            <a:spLocks noGrp="1" noRot="1" noChangeAspect="1"/>
+          </p:cNvSpPr>
+          <p:nvPr>
+            <p:ph type="sldImg"/>
+          </p:nvPr>
+        </p:nvSpPr>
+        <p:spPr/>
+      </p:sp>
+      <p:sp>
+        <p:nvSpPr>
+          <p:cNvPr id="3" name="Notes Placeholder 2"/>
+          <p:cNvSpPr>
+            <a:spLocks noGrp="1"/>
+          </p:cNvSpPr>
+          <p:nvPr>
+            <p:ph type="body" idx="1"/>
+          </p:nvPr>
+        </p:nvSpPr>
+        <p:spPr/>
+        <p:txBody>
+          <a:bodyPr/>
+          <a:lstStyle/>
+          <a:p>
+            <a:endParaRPr lang="en-US" dirty="0"/>
+          </a:p>
+        </p:txBody>
+      </p:sp>
+      <p:sp>
+        <p:nvSpPr>
+          <p:cNvPr id="4" name="Slide Number Placeholder 3"/>
+          <p:cNvSpPr>
+            <a:spLocks noGrp="1"/>
+          </p:cNvSpPr>
+          <p:nvPr>
+            <p:ph type="sldNum" sz="quarter" idx="10"/>
+          </p:nvPr>
+        </p:nvSpPr>
+        <p:spPr/>
+        <p:txBody>
+          <a:bodyPr/>
+          <a:lstStyle/>
+          <a:p>
+            <a:fld id="{F7021451-1387-4CA6-816F-3879F97B5CBC}" type="slidenum">
+              <a:rPr lang="en-US"/>
+              <a:t>8</a:t>
+            </a:fld>
+            <a:endParaRPr lang="en-US"/>
+          </a:p>
+        </p:txBody>
+      </p:sp>
+    </p:spTree>
+    <p:extLst>
+      <p:ext uri="{BB962C8B-B14F-4D97-AF65-F5344CB8AC3E}">
+        <p14:creationId xmlns:p14="http://schemas.microsoft.com/office/powerpoint/2010/main" val="1024086991"/>
+      </p:ext>
+    </p:extLst>
+  </p:cSld>
+  <p:clrMapOvr>
+    <a:masterClrMapping/>
+  </p:clrMapOvr>
+</p:notes>
+</file>
+
+<file path=ppt/notesSlides/notesSlide9.xml><?xml version="1.0" encoding="utf-8"?>
+<p:notes xmlns:a="http://schemas.openxmlformats.org/drawingml/2006/main" xmlns:r="http://schemas.openxmlformats.org/officeDocument/2006/relationships" xmlns:p="http://schemas.openxmlformats.org/presentationml/2006/main">
+  <p:cSld>
+    <p:spTree>
+      <p:nvGrpSpPr>
+        <p:cNvPr id="1" name=""/>
+        <p:cNvGrpSpPr/>
+        <p:nvPr/>
+      </p:nvGrpSpPr>
+      <p:grpSpPr>
+        <a:xfrm>
+          <a:off x="0" y="0"/>
+          <a:ext cx="0" cy="0"/>
+          <a:chOff x="0" y="0"/>
+          <a:chExt cx="0" cy="0"/>
+        </a:xfrm>
+      </p:grpSpPr>
+      <p:sp>
+        <p:nvSpPr>
+          <p:cNvPr id="2" name="Slide Image Placeholder 1"/>
+          <p:cNvSpPr>
+            <a:spLocks noGrp="1" noRot="1" noChangeAspect="1"/>
+          </p:cNvSpPr>
+          <p:nvPr>
+            <p:ph type="sldImg"/>
+          </p:nvPr>
+        </p:nvSpPr>
+        <p:spPr/>
+      </p:sp>
+      <p:sp>
+        <p:nvSpPr>
+          <p:cNvPr id="3" name="Notes Placeholder 2"/>
+          <p:cNvSpPr>
+            <a:spLocks noGrp="1"/>
+          </p:cNvSpPr>
+          <p:nvPr>
+            <p:ph type="body" idx="1"/>
+          </p:nvPr>
+        </p:nvSpPr>
+        <p:spPr/>
+        <p:txBody>
+          <a:bodyPr/>
+          <a:lstStyle/>
+          <a:p>
+            <a:endParaRPr lang="en-US" dirty="0"/>
+          </a:p>
+        </p:txBody>
+      </p:sp>
+      <p:sp>
+        <p:nvSpPr>
+          <p:cNvPr id="4" name="Slide Number Placeholder 3"/>
+          <p:cNvSpPr>
+            <a:spLocks noGrp="1"/>
+          </p:cNvSpPr>
+          <p:nvPr>
+            <p:ph type="sldNum" sz="quarter" idx="10"/>
+          </p:nvPr>
+        </p:nvSpPr>
+        <p:spPr/>
+        <p:txBody>
+          <a:bodyPr/>
+          <a:lstStyle/>
+          <a:p>
+            <a:fld id="{F7021451-1387-4CA6-816F-3879F97B5CBC}" type="slidenum">
+              <a:rPr lang="en-US"/>
+              <a:t>9</a:t>
+            </a:fld>
+            <a:endParaRPr lang="en-US"/>
+          </a:p>
+        </p:txBody>
+      </p:sp>
+    </p:spTree>
+    <p:extLst>
+      <p:ext uri="{BB962C8B-B14F-4D97-AF65-F5344CB8AC3E}">
+        <p14:creationId xmlns:p14="http://schemas.microsoft.com/office/powerpoint/2010/main" val="1024086991"/>
+      </p:ext>
+    </p:extLst>
+  </p:cSld>
+  <p:clrMapOvr>
+    <a:masterClrMapping/>
+  </p:clrMapOvr>
+</p:notes>
+</file>
+
 <file path=ppt/slideLayouts/slideLayout1.xml><?xml version="1.0" encoding="utf-8"?>
 <p:sldLayout xmlns:a="http://schemas.openxmlformats.org/drawingml/2006/main" xmlns:r="http://schemas.openxmlformats.org/officeDocument/2006/relationships" xmlns:p="http://schemas.openxmlformats.org/presentationml/2006/main">
   <p:cSld name="DEFAULT">
@@ -695,9 +1035,12 @@
 <p:sldMaster xmlns:a="http://schemas.openxmlformats.org/drawingml/2006/main" xmlns:r="http://schemas.openxmlformats.org/officeDocument/2006/relationships" xmlns:p="http://schemas.openxmlformats.org/presentationml/2006/main">
   <p:cSld>
     <p:bg>
-      <p:bgRef idx="1001">
-        <a:schemeClr val="bg1"/>
-      </p:bgRef>
+      <p:bgPr>
+        <a:solidFill>
+          <a:srgbClr val="FFFFFF"/>
+        </a:solidFill>
+        <a:effectLst/>
+      </p:bgPr>
     </p:bg>
     <p:spTree>
       <p:nvGrpSpPr>
@@ -713,11 +1056,40 @@
           <a:chExt cx="0" cy="0"/>
         </a:xfrm>
       </p:grpSpPr>
+      <p:sp>
+        <p:nvSpPr>
+          <p:cNvPr id="900" name="AccentLine"/>
+          <p:cNvSpPr/>
+          <p:nvPr userDrawn="1"/>
+        </p:nvSpPr>
+        <p:spPr>
+          <a:xfrm>
+            <a:off x="457200" y="6400800"/>
+            <a:ext cx="8229600" cy="18288"/>
+          </a:xfrm>
+          <a:prstGeom prst="rect">
+            <a:avLst/>
+          </a:prstGeom>
+          <a:solidFill>
+            <a:srgbClr val="E8E8EC"/>
+          </a:solidFill>
+          <a:ln>
+            <a:noFill/>
+          </a:ln>
+        </p:spPr>
+        <p:txBody>
+          <a:bodyPr/>
+          <a:lstStyle/>
+          <a:p>
+            <a:endParaRPr lang="en-US"/>
+          </a:p>
+        </p:txBody>
+      </p:sp>
     </p:spTree>
   </p:cSld>
   <p:clrMap bg1="lt1" tx1="dk1" bg2="lt2" tx2="dk2" accent1="accent1" accent2="accent2" accent3="accent3" accent4="accent4" accent5="accent5" accent6="accent6" hlink="hlink" folHlink="folHlink"/>
   <p:sldLayoutIdLst>
-    <p:sldLayoutId id="2147483651" r:id="rId1"/>
+    <p:sldLayoutId id="2147483653" r:id="rId1"/>
   </p:sldLayoutIdLst>
   <p:hf sldNum="0" hdr="0" ftr="0" dt="0"/>
   <p:txStyles>
@@ -729,7 +1101,7 @@
         <a:buNone/>
         <a:defRPr sz="4400" kern="1200">
           <a:solidFill>
-            <a:schemeClr val="tx1"/>
+            <a:srgbClr val="1A1A2E"/>
           </a:solidFill>
           <a:latin typeface="+mj-lt"/>
           <a:ea typeface="+mj-ea"/>
@@ -746,7 +1118,7 @@
         <a:buChar char="•"/>
         <a:defRPr sz="3200" kern="1200">
           <a:solidFill>
-            <a:schemeClr val="tx1"/>
+            <a:srgbClr val="3D3D5C"/>
           </a:solidFill>
           <a:latin typeface="+mn-lt"/>
           <a:ea typeface="+mn-ea"/>
@@ -761,7 +1133,7 @@
         <a:buChar char="–"/>
         <a:defRPr sz="2800" kern="1200">
           <a:solidFill>
-            <a:schemeClr val="tx1"/>
+            <a:srgbClr val="3D3D5C"/>
           </a:solidFill>
           <a:latin typeface="+mn-lt"/>
           <a:ea typeface="+mn-ea"/>
@@ -776,7 +1148,7 @@
         <a:buChar char="•"/>
         <a:defRPr sz="2400" kern="1200">
           <a:solidFill>
-            <a:schemeClr val="tx1"/>
+            <a:srgbClr val="3D3D5C"/>
           </a:solidFill>
           <a:latin typeface="+mn-lt"/>
           <a:ea typeface="+mn-ea"/>
@@ -791,7 +1163,7 @@
         <a:buChar char="–"/>
         <a:defRPr sz="2000" kern="1200">
           <a:solidFill>
-            <a:schemeClr val="tx1"/>
+            <a:srgbClr val="3D3D5C"/>
           </a:solidFill>
           <a:latin typeface="+mn-lt"/>
           <a:ea typeface="+mn-ea"/>
@@ -806,7 +1178,7 @@
         <a:buChar char="»"/>
         <a:defRPr sz="2000" kern="1200">
           <a:solidFill>
-            <a:schemeClr val="tx1"/>
+            <a:srgbClr val="3D3D5C"/>
           </a:solidFill>
           <a:latin typeface="+mn-lt"/>
           <a:ea typeface="+mn-ea"/>
@@ -1002,57 +1374,23 @@
       </p:grpSpPr>
       <p:sp>
         <p:nvSpPr>
-          <p:cNvPr id="2" name="Shape 0"/>
-          <p:cNvSpPr/>
-          <p:nvPr/>
-        </p:nvSpPr>
-        <p:spPr>
-          <a:xfrm>
-            <a:off x="0" y="0"/>
-            <a:ext cx="50800" cy="5143500"/>
+          <p:cNvPr id="17" name="Shape 15"/>
+          <p:cNvSpPr/>
+          <p:nvPr/>
+        </p:nvSpPr>
+        <p:spPr>
+          <a:xfrm>
+            <a:off x="508000" y="2184400"/>
+            <a:ext cx="3810000" cy="19050"/>
           </a:xfrm>
           <a:prstGeom prst="rect">
             <a:avLst/>
           </a:prstGeom>
           <a:solidFill>
-            <a:srgbClr val="001A5C"/>
+            <a:srgbClr val="E8E8EC"/>
           </a:solidFill>
           <a:ln w="12700">
-            <a:solidFill>
-              <a:srgbClr val="333333"/>
-            </a:solidFill>
-            <a:prstDash val="solid"/>
-          </a:ln>
-        </p:spPr>
-        <p:txBody>
-          <a:bodyPr/>
-          <a:lstStyle/>
-          <a:p>
-            <a:endParaRPr lang="en-US"/>
-          </a:p>
-        </p:txBody>
-      </p:sp>
-      <p:sp>
-        <p:nvSpPr>
-          <p:cNvPr id="17" name="Shape 15"/>
-          <p:cNvSpPr/>
-          <p:nvPr/>
-        </p:nvSpPr>
-        <p:spPr>
-          <a:xfrm>
-            <a:off x="508000" y="2184400"/>
-            <a:ext cx="3302000" cy="22860"/>
-          </a:xfrm>
-          <a:prstGeom prst="rect">
-            <a:avLst/>
-          </a:prstGeom>
-          <a:solidFill>
-            <a:srgbClr val="001A5C"/>
-          </a:solidFill>
-          <a:ln w="12700">
-            <a:solidFill>
-              <a:srgbClr val="333333"/>
-            </a:solidFill>
+            <a:noFill/>
             <a:prstDash val="solid"/>
           </a:ln>
         </p:spPr>
@@ -1214,7 +1552,7 @@
     </p:spTree>
     <p:extLst>
       <p:ext uri="{BB962C8B-B14F-4D97-AF65-F5344CB8AC3E}">
-        <p14:creationId xmlns:p14="http://schemas.microsoft.com/office/powerpoint/2010/main" val="1304269759"/>
+        <p14:creationId xmlns:p14="http://schemas.microsoft.com/office/powerpoint/2010/main" val="1960991967"/>
       </p:ext>
     </p:extLst>
   </p:cSld>
@@ -1787,7 +2125,7 @@
         <p:spPr>
           <a:xfrm>
             <a:off x="3794760" y="1005840"/>
-            <a:ext cx="5029200" cy="2011680"/>
+            <a:ext cx="5029200" cy="3708400"/>
           </a:xfrm>
           <a:prstGeom prst="rect">
             <a:avLst/>
@@ -1822,14 +2160,678 @@
       </p:sp>
       <p:sp>
         <p:nvSpPr>
+          <p:cNvPr id="21" name="Rectangle 20">
+            <a:extLst>
+              <a:ext uri="{FF2B5EF4-FFF2-40B4-BE49-F238E27FC236}">
+                <a16:creationId xmlns:a16="http://schemas.microsoft.com/office/drawing/2014/main" id="{BAB323C8-CACD-0E4D-A695-6D3B7F259D03}"/>
+              </a:ext>
+            </a:extLst>
+          </p:cNvPr>
+          <p:cNvSpPr/>
+          <p:nvPr/>
+        </p:nvSpPr>
+        <p:spPr>
+          <a:xfrm>
+            <a:off x="317500" y="4457700"/>
+            <a:ext cx="50800" cy="342900"/>
+          </a:xfrm>
+          <a:prstGeom prst="rect">
+            <a:avLst/>
+          </a:prstGeom>
+          <a:solidFill>
+            <a:srgbClr val="C8102E"/>
+          </a:solidFill>
+          <a:ln w="12700" cap="flat" cmpd="sng" algn="ctr">
+            <a:noFill/>
+            <a:prstDash val="solid"/>
+            <a:miter lim="800000"/>
+          </a:ln>
+        </p:spPr>
+        <p:style>
+          <a:lnRef idx="2">
+            <a:schemeClr val="accent1">
+              <a:shade val="15000"/>
+            </a:schemeClr>
+          </a:lnRef>
+          <a:fillRef idx="1">
+            <a:schemeClr val="accent1"/>
+          </a:fillRef>
+          <a:effectRef idx="0">
+            <a:schemeClr val="accent1"/>
+          </a:effectRef>
+          <a:fontRef idx="minor">
+            <a:schemeClr val="lt1"/>
+          </a:fontRef>
+        </p:style>
+        <p:txBody>
+          <a:bodyPr vertOverflow="clip" horzOverflow="clip" rtlCol="0" anchor="t"/>
+          <a:lstStyle/>
+          <a:p>
+            <a:pPr algn="l"/>
+            <a:endParaRPr lang="en-US"/>
+          </a:p>
+        </p:txBody>
+      </p:sp>
+      <p:sp>
+        <p:nvSpPr>
+          <p:cNvPr id="22" name="TextBox 21">
+            <a:extLst>
+              <a:ext uri="{FF2B5EF4-FFF2-40B4-BE49-F238E27FC236}">
+                <a16:creationId xmlns:a16="http://schemas.microsoft.com/office/drawing/2014/main" id="{B5C22D72-E212-994F-8880-D1FADA7A2C74}"/>
+              </a:ext>
+            </a:extLst>
+          </p:cNvPr>
+          <p:cNvSpPr txBox="1"/>
+          <p:nvPr/>
+        </p:nvSpPr>
+        <p:spPr>
+          <a:xfrm>
+            <a:off x="469900" y="4457700"/>
+            <a:ext cx="1092200" cy="342900"/>
+          </a:xfrm>
+          <a:prstGeom prst="rect">
+            <a:avLst/>
+          </a:prstGeom>
+          <a:noFill/>
+        </p:spPr>
+        <p:txBody>
+          <a:bodyPr vertOverflow="overflow" vert="horz" wrap="square" rtlCol="0" anchor="ctr" anchorCtr="0">
+            <a:noAutofit/>
+          </a:bodyPr>
+          <a:lstStyle/>
+          <a:p>
+            <a:pPr algn="l"/>
+            <a:r>
+              <a:rPr lang="en-US" b="1" dirty="0">
+                <a:solidFill>
+                  <a:srgbClr val="FFFFFF"/>
+                </a:solidFill>
+                <a:latin typeface="Avenir"/>
+              </a:rPr>
+              <a:t>41.6m</a:t>
+            </a:r>
+          </a:p>
+        </p:txBody>
+      </p:sp>
+      <p:sp>
+        <p:nvSpPr>
+          <p:cNvPr id="23" name="TextBox 22">
+            <a:extLst>
+              <a:ext uri="{FF2B5EF4-FFF2-40B4-BE49-F238E27FC236}">
+                <a16:creationId xmlns:a16="http://schemas.microsoft.com/office/drawing/2014/main" id="{9BF888F5-3047-7342-868B-8286DFC3CEC4}"/>
+              </a:ext>
+            </a:extLst>
+          </p:cNvPr>
+          <p:cNvSpPr txBox="1"/>
+          <p:nvPr/>
+        </p:nvSpPr>
+        <p:spPr>
+          <a:xfrm>
+            <a:off x="1574800" y="4533900"/>
+            <a:ext cx="1739900" cy="254000"/>
+          </a:xfrm>
+          <a:prstGeom prst="rect">
+            <a:avLst/>
+          </a:prstGeom>
+          <a:noFill/>
+        </p:spPr>
+        <p:txBody>
+          <a:bodyPr vertOverflow="overflow" vert="horz" wrap="square" rtlCol="0" anchor="ctr" anchorCtr="0">
+            <a:noAutofit/>
+          </a:bodyPr>
+          <a:lstStyle/>
+          <a:p>
+            <a:pPr algn="l"/>
+            <a:r>
+              <a:rPr lang="en-US" sz="1000" dirty="0">
+                <a:solidFill>
+                  <a:srgbClr val="CADCFC"/>
+                </a:solidFill>
+                <a:latin typeface="Avenir"/>
+              </a:rPr>
+              <a:t>Organic community across social media</a:t>
+            </a:r>
+          </a:p>
+        </p:txBody>
+      </p:sp>
+    </p:spTree>
+    <p:extLst>
+      <p:ext uri="{BB962C8B-B14F-4D97-AF65-F5344CB8AC3E}">
+        <p14:creationId xmlns:p14="http://schemas.microsoft.com/office/powerpoint/2010/main" val="930793777"/>
+      </p:ext>
+    </p:extLst>
+  </p:cSld>
+  <p:clrMapOvr>
+    <a:masterClrMapping/>
+  </p:clrMapOvr>
+</p:sld>
+</file>
+
+<file path=ppt/slides/slide3.xml><?xml version="1.0" encoding="utf-8"?>
+<p:sld xmlns:a="http://schemas.openxmlformats.org/drawingml/2006/main" xmlns:r="http://schemas.openxmlformats.org/officeDocument/2006/relationships" xmlns:p="http://schemas.openxmlformats.org/presentationml/2006/main">
+  <p:cSld name="Slide 2">
+    <p:bg>
+      <p:bgPr>
+        <a:solidFill>
+          <a:srgbClr val="FFFFFF"/>
+        </a:solidFill>
+        <a:effectLst/>
+      </p:bgPr>
+    </p:bg>
+    <p:spTree>
+      <p:nvGrpSpPr>
+        <p:cNvPr id="1" name=""/>
+        <p:cNvGrpSpPr/>
+        <p:nvPr/>
+      </p:nvGrpSpPr>
+      <p:grpSpPr>
+        <a:xfrm>
+          <a:off x="0" y="0"/>
+          <a:ext cx="0" cy="0"/>
+          <a:chOff x="0" y="0"/>
+          <a:chExt cx="0" cy="0"/>
+        </a:xfrm>
+      </p:grpSpPr>
+      <p:sp>
+        <p:nvSpPr>
+          <p:cNvPr id="2" name="Shape 0"/>
+          <p:cNvSpPr/>
+          <p:nvPr/>
+        </p:nvSpPr>
+        <p:spPr>
+          <a:xfrm>
+            <a:off x="0" y="0"/>
+            <a:ext cx="3474720" cy="5143500"/>
+          </a:xfrm>
+          <a:prstGeom prst="rect">
+            <a:avLst/>
+          </a:prstGeom>
+          <a:solidFill>
+            <a:srgbClr val="0B1F4B"/>
+          </a:solidFill>
+          <a:ln w="12700">
+            <a:solidFill>
+              <a:srgbClr val="333333"/>
+            </a:solidFill>
+            <a:prstDash val="solid"/>
+          </a:ln>
+        </p:spPr>
+        <p:txBody>
+          <a:bodyPr/>
+          <a:lstStyle/>
+          <a:p>
+            <a:endParaRPr lang="en-US" dirty="0"/>
+          </a:p>
+        </p:txBody>
+      </p:sp>
+      <p:sp>
+        <p:nvSpPr>
+          <p:cNvPr id="3" name="Shape 1"/>
+          <p:cNvSpPr/>
+          <p:nvPr/>
+        </p:nvSpPr>
+        <p:spPr>
+          <a:xfrm>
+            <a:off x="3474720" y="0"/>
+            <a:ext cx="54864" cy="5143500"/>
+          </a:xfrm>
+          <a:prstGeom prst="rect">
+            <a:avLst/>
+          </a:prstGeom>
+          <a:solidFill>
+            <a:srgbClr val="C8102E"/>
+          </a:solidFill>
+          <a:ln w="12700">
+            <a:solidFill>
+              <a:srgbClr val="333333"/>
+            </a:solidFill>
+            <a:prstDash val="solid"/>
+          </a:ln>
+        </p:spPr>
+        <p:txBody>
+          <a:bodyPr/>
+          <a:lstStyle/>
+          <a:p>
+            <a:endParaRPr lang="en-US"/>
+          </a:p>
+        </p:txBody>
+      </p:sp>
+      <p:sp>
+        <p:nvSpPr>
+          <p:cNvPr id="4" name="Text 2"/>
+          <p:cNvSpPr/>
+          <p:nvPr/>
+        </p:nvSpPr>
+        <p:spPr>
+          <a:xfrm>
+            <a:off x="320040" y="136679"/>
+            <a:ext cx="2834640" cy="914400"/>
+          </a:xfrm>
+          <a:prstGeom prst="rect">
+            <a:avLst/>
+          </a:prstGeom>
+          <a:noFill/>
+          <a:ln/>
+        </p:spPr>
+        <p:txBody>
+          <a:bodyPr wrap="square" lIns="0" tIns="0" rIns="0" bIns="0" rtlCol="0" anchor="ctr"/>
+          <a:lstStyle/>
+          <a:p>
+            <a:pPr marL="0" indent="0" algn="l">
+              <a:buNone/>
+            </a:pPr>
+            <a:r>
+              <a:rPr lang="en-US" sz="2800" b="1" dirty="0">
+                <a:solidFill>
+                  <a:srgbClr val="FFFFFF"/>
+                </a:solidFill>
+                <a:latin typeface="Avenir" pitchFamily="34" charset="0"/>
+                <a:ea typeface="Avenir" pitchFamily="34" charset="-122"/>
+                <a:cs typeface="Avenir" pitchFamily="34" charset="-120"/>
+              </a:rPr>
+              <a:t>WHO</a:t>
+            </a:r>
+            <a:r>
+              <a:rPr lang="en-US" sz="2800" dirty="0"/>
+              <a:t> </a:t>
+            </a:r>
+            <a:r>
+              <a:rPr lang="en-US" sz="2800" b="1" dirty="0">
+                <a:solidFill>
+                  <a:srgbClr val="FFFFFF"/>
+                </a:solidFill>
+                <a:latin typeface="Avenir" pitchFamily="34" charset="0"/>
+                <a:ea typeface="Avenir" pitchFamily="34" charset="-122"/>
+                <a:cs typeface="Avenir" pitchFamily="34" charset="-120"/>
+              </a:rPr>
+              <a:t>WE ARE</a:t>
+            </a:r>
+            <a:endParaRPr lang="en-US" sz="2800" dirty="0"/>
+          </a:p>
+        </p:txBody>
+      </p:sp>
+      <p:sp>
+        <p:nvSpPr>
+          <p:cNvPr id="5" name="Text 3"/>
+          <p:cNvSpPr/>
+          <p:nvPr/>
+        </p:nvSpPr>
+        <p:spPr>
+          <a:xfrm>
+            <a:off x="320040" y="1005840"/>
+            <a:ext cx="2834640" cy="1645920"/>
+          </a:xfrm>
+          <a:prstGeom prst="rect">
+            <a:avLst/>
+          </a:prstGeom>
+          <a:noFill/>
+          <a:ln/>
+        </p:spPr>
+        <p:txBody>
+          <a:bodyPr wrap="square" lIns="0" tIns="0" rIns="0" bIns="0" rtlCol="0" anchor="ctr"/>
+          <a:lstStyle/>
+          <a:p>
+            <a:pPr>
+              <a:lnSpc>
+                <a:spcPct val="130000"/>
+              </a:lnSpc>
+            </a:pPr>
+            <a:r>
+              <a:rPr lang="en-PH" sz="1200" dirty="0">
+                <a:solidFill>
+                  <a:schemeClr val="bg1"/>
+                </a:solidFill>
+              </a:rPr>
+              <a:t>MBC Media Group is the Philippines' most integrated media powerhouse — a broadcasting institution founded in 1939, operating 6 strategic business units (Radio, TV, Digital, Promos, Events, and Talents) to deliver seamless campaigns on air, online, and on-ground.</a:t>
+            </a:r>
+            <a:endParaRPr lang="en-US" sz="1150" dirty="0">
+              <a:solidFill>
+                <a:schemeClr val="bg1"/>
+              </a:solidFill>
+            </a:endParaRPr>
+          </a:p>
+        </p:txBody>
+      </p:sp>
+      <p:sp>
+        <p:nvSpPr>
+          <p:cNvPr id="6" name="Shape 4"/>
+          <p:cNvSpPr/>
+          <p:nvPr/>
+        </p:nvSpPr>
+        <p:spPr>
+          <a:xfrm>
+            <a:off x="317500" y="2857500"/>
+            <a:ext cx="50800" cy="342900"/>
+          </a:xfrm>
+          <a:prstGeom prst="rect">
+            <a:avLst/>
+          </a:prstGeom>
+          <a:solidFill>
+            <a:srgbClr val="C8102E"/>
+          </a:solidFill>
+          <a:ln w="12700">
+            <a:solidFill>
+              <a:srgbClr val="333333"/>
+            </a:solidFill>
+            <a:prstDash val="solid"/>
+          </a:ln>
+        </p:spPr>
+        <p:txBody>
+          <a:bodyPr/>
+          <a:lstStyle/>
+          <a:p>
+            <a:endParaRPr lang="en-US"/>
+          </a:p>
+        </p:txBody>
+      </p:sp>
+      <p:sp>
+        <p:nvSpPr>
+          <p:cNvPr id="7" name="Text 5"/>
+          <p:cNvSpPr/>
+          <p:nvPr/>
+        </p:nvSpPr>
+        <p:spPr>
+          <a:xfrm>
+            <a:off x="469900" y="2857500"/>
+            <a:ext cx="1092200" cy="342900"/>
+          </a:xfrm>
+          <a:prstGeom prst="rect">
+            <a:avLst/>
+          </a:prstGeom>
+          <a:noFill/>
+          <a:ln/>
+        </p:spPr>
+        <p:txBody>
+          <a:bodyPr wrap="square" lIns="0" tIns="0" rIns="0" bIns="0" rtlCol="0" anchor="ctr"/>
+          <a:lstStyle/>
+          <a:p>
+            <a:pPr marL="0" indent="0">
+              <a:buNone/>
+            </a:pPr>
+            <a:r>
+              <a:rPr lang="en-US" sz="1800" b="1" dirty="0">
+                <a:solidFill>
+                  <a:srgbClr val="FFFFFF"/>
+                </a:solidFill>
+                <a:latin typeface="Avenir" pitchFamily="34" charset="0"/>
+                <a:ea typeface="Avenir" pitchFamily="34" charset="-122"/>
+                <a:cs typeface="Avenir" pitchFamily="34" charset="-120"/>
+              </a:rPr>
+              <a:t>85+</a:t>
+            </a:r>
+            <a:endParaRPr lang="en-US" sz="1800" dirty="0"/>
+          </a:p>
+        </p:txBody>
+      </p:sp>
+      <p:sp>
+        <p:nvSpPr>
+          <p:cNvPr id="8" name="Text 6"/>
+          <p:cNvSpPr/>
+          <p:nvPr/>
+        </p:nvSpPr>
+        <p:spPr>
+          <a:xfrm>
+            <a:off x="1574800" y="2933700"/>
+            <a:ext cx="1739900" cy="254000"/>
+          </a:xfrm>
+          <a:prstGeom prst="rect">
+            <a:avLst/>
+          </a:prstGeom>
+          <a:noFill/>
+          <a:ln/>
+        </p:spPr>
+        <p:txBody>
+          <a:bodyPr wrap="square" lIns="0" tIns="0" rIns="0" bIns="0" rtlCol="0" anchor="ctr"/>
+          <a:lstStyle/>
+          <a:p>
+            <a:pPr marL="0" indent="0">
+              <a:buNone/>
+            </a:pPr>
+            <a:r>
+              <a:rPr lang="en-US" sz="1000" dirty="0">
+                <a:solidFill>
+                  <a:srgbClr val="CADCFC"/>
+                </a:solidFill>
+                <a:latin typeface="Avenir" pitchFamily="34" charset="0"/>
+                <a:ea typeface="Avenir" pitchFamily="34" charset="-122"/>
+                <a:cs typeface="Avenir" pitchFamily="34" charset="-120"/>
+              </a:rPr>
+              <a:t>Years on air</a:t>
+            </a:r>
+            <a:endParaRPr lang="en-US" sz="1000" dirty="0"/>
+          </a:p>
+        </p:txBody>
+      </p:sp>
+      <p:sp>
+        <p:nvSpPr>
+          <p:cNvPr id="9" name="Shape 7"/>
+          <p:cNvSpPr/>
+          <p:nvPr/>
+        </p:nvSpPr>
+        <p:spPr>
+          <a:xfrm>
+            <a:off x="317500" y="3390900"/>
+            <a:ext cx="50800" cy="342900"/>
+          </a:xfrm>
+          <a:prstGeom prst="rect">
+            <a:avLst/>
+          </a:prstGeom>
+          <a:solidFill>
+            <a:srgbClr val="C8102E"/>
+          </a:solidFill>
+          <a:ln w="12700">
+            <a:solidFill>
+              <a:srgbClr val="333333"/>
+            </a:solidFill>
+            <a:prstDash val="solid"/>
+          </a:ln>
+        </p:spPr>
+        <p:txBody>
+          <a:bodyPr/>
+          <a:lstStyle/>
+          <a:p>
+            <a:endParaRPr lang="en-US"/>
+          </a:p>
+        </p:txBody>
+      </p:sp>
+      <p:sp>
+        <p:nvSpPr>
+          <p:cNvPr id="10" name="Text 8"/>
+          <p:cNvSpPr/>
+          <p:nvPr/>
+        </p:nvSpPr>
+        <p:spPr>
+          <a:xfrm>
+            <a:off x="469900" y="3390900"/>
+            <a:ext cx="1092200" cy="342900"/>
+          </a:xfrm>
+          <a:prstGeom prst="rect">
+            <a:avLst/>
+          </a:prstGeom>
+          <a:noFill/>
+          <a:ln/>
+        </p:spPr>
+        <p:txBody>
+          <a:bodyPr wrap="square" lIns="0" tIns="0" rIns="0" bIns="0" rtlCol="0" anchor="ctr"/>
+          <a:lstStyle/>
+          <a:p>
+            <a:pPr marL="0" indent="0">
+              <a:buNone/>
+            </a:pPr>
+            <a:r>
+              <a:rPr lang="en-US" sz="1800" b="1" dirty="0">
+                <a:solidFill>
+                  <a:srgbClr val="FFFFFF"/>
+                </a:solidFill>
+                <a:latin typeface="Avenir" pitchFamily="34" charset="0"/>
+                <a:ea typeface="Avenir" pitchFamily="34" charset="-122"/>
+                <a:cs typeface="Avenir" pitchFamily="34" charset="-120"/>
+              </a:rPr>
+              <a:t>200</a:t>
+            </a:r>
+            <a:endParaRPr lang="en-US" sz="1800" dirty="0"/>
+          </a:p>
+        </p:txBody>
+      </p:sp>
+      <p:sp>
+        <p:nvSpPr>
+          <p:cNvPr id="11" name="Text 9"/>
+          <p:cNvSpPr/>
+          <p:nvPr/>
+        </p:nvSpPr>
+        <p:spPr>
+          <a:xfrm>
+            <a:off x="1574800" y="3467100"/>
+            <a:ext cx="1739900" cy="254000"/>
+          </a:xfrm>
+          <a:prstGeom prst="rect">
+            <a:avLst/>
+          </a:prstGeom>
+          <a:noFill/>
+          <a:ln/>
+        </p:spPr>
+        <p:txBody>
+          <a:bodyPr wrap="square" lIns="0" tIns="0" rIns="0" bIns="0" rtlCol="0" anchor="ctr"/>
+          <a:lstStyle/>
+          <a:p>
+            <a:pPr marL="0" indent="0">
+              <a:buNone/>
+            </a:pPr>
+            <a:r>
+              <a:rPr lang="en-US" sz="1000" dirty="0">
+                <a:solidFill>
+                  <a:srgbClr val="CADCFC"/>
+                </a:solidFill>
+                <a:latin typeface="Avenir" pitchFamily="34" charset="0"/>
+                <a:ea typeface="Avenir" pitchFamily="34" charset="-122"/>
+                <a:cs typeface="Avenir" pitchFamily="34" charset="-120"/>
+              </a:rPr>
+              <a:t>Radio stations</a:t>
+            </a:r>
+            <a:endParaRPr lang="en-US" sz="1000" dirty="0"/>
+          </a:p>
+        </p:txBody>
+      </p:sp>
+      <p:sp>
+        <p:nvSpPr>
+          <p:cNvPr id="12" name="Shape 10"/>
+          <p:cNvSpPr/>
+          <p:nvPr/>
+        </p:nvSpPr>
+        <p:spPr>
+          <a:xfrm>
+            <a:off x="317500" y="3924300"/>
+            <a:ext cx="50800" cy="342900"/>
+          </a:xfrm>
+          <a:prstGeom prst="rect">
+            <a:avLst/>
+          </a:prstGeom>
+          <a:solidFill>
+            <a:srgbClr val="C8102E"/>
+          </a:solidFill>
+          <a:ln w="12700">
+            <a:solidFill>
+              <a:srgbClr val="333333"/>
+            </a:solidFill>
+            <a:prstDash val="solid"/>
+          </a:ln>
+        </p:spPr>
+        <p:txBody>
+          <a:bodyPr/>
+          <a:lstStyle/>
+          <a:p>
+            <a:endParaRPr lang="en-US"/>
+          </a:p>
+        </p:txBody>
+      </p:sp>
+      <p:sp>
+        <p:nvSpPr>
+          <p:cNvPr id="13" name="Text 11"/>
+          <p:cNvSpPr/>
+          <p:nvPr/>
+        </p:nvSpPr>
+        <p:spPr>
+          <a:xfrm>
+            <a:off x="469900" y="3924300"/>
+            <a:ext cx="1092200" cy="342900"/>
+          </a:xfrm>
+          <a:prstGeom prst="rect">
+            <a:avLst/>
+          </a:prstGeom>
+          <a:noFill/>
+          <a:ln/>
+        </p:spPr>
+        <p:txBody>
+          <a:bodyPr wrap="square" lIns="0" tIns="0" rIns="0" bIns="0" rtlCol="0" anchor="ctr"/>
+          <a:lstStyle/>
+          <a:p>
+            <a:pPr marL="0" indent="0">
+              <a:buNone/>
+            </a:pPr>
+            <a:r>
+              <a:rPr lang="en-US" sz="1800" b="1" dirty="0">
+                <a:solidFill>
+                  <a:srgbClr val="FFFFFF"/>
+                </a:solidFill>
+                <a:latin typeface="Avenir" pitchFamily="34" charset="0"/>
+                <a:ea typeface="Avenir" pitchFamily="34" charset="-122"/>
+                <a:cs typeface="Avenir" pitchFamily="34" charset="-120"/>
+              </a:rPr>
+              <a:t>6</a:t>
+            </a:r>
+            <a:endParaRPr lang="en-US" sz="1800" dirty="0"/>
+          </a:p>
+        </p:txBody>
+      </p:sp>
+      <p:sp>
+        <p:nvSpPr>
+          <p:cNvPr id="14" name="Text 12"/>
+          <p:cNvSpPr/>
+          <p:nvPr/>
+        </p:nvSpPr>
+        <p:spPr>
+          <a:xfrm>
+            <a:off x="1574800" y="4000500"/>
+            <a:ext cx="1739900" cy="254000"/>
+          </a:xfrm>
+          <a:prstGeom prst="rect">
+            <a:avLst/>
+          </a:prstGeom>
+          <a:noFill/>
+          <a:ln/>
+        </p:spPr>
+        <p:txBody>
+          <a:bodyPr wrap="square" lIns="0" tIns="0" rIns="0" bIns="0" rtlCol="0" anchor="ctr"/>
+          <a:lstStyle/>
+          <a:p>
+            <a:pPr marL="0" indent="0">
+              <a:buNone/>
+            </a:pPr>
+            <a:r>
+              <a:rPr lang="en-US" sz="1000" dirty="0">
+                <a:solidFill>
+                  <a:srgbClr val="CADCFC"/>
+                </a:solidFill>
+                <a:latin typeface="Avenir" pitchFamily="34" charset="0"/>
+                <a:ea typeface="Avenir" pitchFamily="34" charset="-122"/>
+                <a:cs typeface="Avenir" pitchFamily="34" charset="-120"/>
+              </a:rPr>
+              <a:t>Integrated business units</a:t>
+            </a:r>
+            <a:endParaRPr lang="en-US" sz="1000" dirty="0"/>
+          </a:p>
+        </p:txBody>
+      </p:sp>
+      <p:sp>
+        <p:nvSpPr>
           <p:cNvPr id="17" name="Shape 15"/>
           <p:cNvSpPr/>
           <p:nvPr/>
         </p:nvSpPr>
         <p:spPr>
           <a:xfrm>
-            <a:off x="3794760" y="3200400"/>
-            <a:ext cx="5029200" cy="1508760"/>
+            <a:off x="3794760" y="508000"/>
+            <a:ext cx="5029200" cy="4203700"/>
           </a:xfrm>
           <a:prstGeom prst="rect">
             <a:avLst/>
@@ -1867,8 +2869,8 @@
         </p:nvSpPr>
         <p:spPr>
           <a:xfrm>
-            <a:off x="3794760" y="3200400"/>
-            <a:ext cx="64008" cy="1508760"/>
+            <a:off x="3794760" y="508000"/>
+            <a:ext cx="64008" cy="4203700"/>
           </a:xfrm>
           <a:prstGeom prst="rect">
             <a:avLst/>
@@ -1899,7 +2901,7 @@
         </p:nvSpPr>
         <p:spPr>
           <a:xfrm>
-            <a:off x="3977640" y="3310128"/>
+            <a:off x="3977640" y="635000"/>
             <a:ext cx="4663440" cy="274320"/>
           </a:xfrm>
           <a:prstGeom prst="rect">
@@ -1938,8 +2940,8 @@
         </p:nvSpPr>
         <p:spPr>
           <a:xfrm>
-            <a:off x="3977640" y="3657600"/>
-            <a:ext cx="4663440" cy="914400"/>
+            <a:off x="3977640" y="1016000"/>
+            <a:ext cx="4663440" cy="3568700"/>
           </a:xfrm>
           <a:prstGeom prst="rect">
             <a:avLst/>
@@ -2111,7 +3113,7 @@
     </p:spTree>
     <p:extLst>
       <p:ext uri="{BB962C8B-B14F-4D97-AF65-F5344CB8AC3E}">
-        <p14:creationId xmlns:p14="http://schemas.microsoft.com/office/powerpoint/2010/main" val="930793777"/>
+        <p14:creationId xmlns:p14="http://schemas.microsoft.com/office/powerpoint/2010/main" val="361654629"/>
       </p:ext>
     </p:extLst>
   </p:cSld>
@@ -2121,7 +3123,7 @@
 </p:sld>
 </file>
 
-<file path=ppt/slides/slide3.xml><?xml version="1.0" encoding="utf-8"?>
+<file path=ppt/slides/slide4.xml><?xml version="1.0" encoding="utf-8"?>
 <p:sld xmlns:a="http://schemas.openxmlformats.org/drawingml/2006/main" xmlns:r="http://schemas.openxmlformats.org/officeDocument/2006/relationships" xmlns:p="http://schemas.openxmlformats.org/presentationml/2006/main">
   <p:cSld name="Slide 3">
     <p:bg>
@@ -2258,7 +3260,7 @@
         <p:spPr>
           <a:xfrm>
             <a:off x="419100" y="1188719"/>
-            <a:ext cx="2590800" cy="3832985"/>
+            <a:ext cx="8305800" cy="3832985"/>
           </a:xfrm>
           <a:prstGeom prst="rect">
             <a:avLst/>
@@ -2297,7 +3299,7 @@
         <p:spPr>
           <a:xfrm>
             <a:off x="419100" y="1188720"/>
-            <a:ext cx="2590800" cy="73152"/>
+            <a:ext cx="8305800" cy="73152"/>
           </a:xfrm>
           <a:prstGeom prst="rect">
             <a:avLst/>
@@ -2322,16 +3324,135 @@
       </p:sp>
       <p:sp>
         <p:nvSpPr>
-          <p:cNvPr id="7" name="Shape 5"/>
-          <p:cNvSpPr/>
-          <p:nvPr/>
-        </p:nvSpPr>
-        <p:spPr>
-          <a:xfrm>
-            <a:off x="584200" y="1371600"/>
-            <a:ext cx="502920" cy="502920"/>
-          </a:xfrm>
-          <a:prstGeom prst="ellipse">
+          <p:cNvPr id="9" name="Text 7"/>
+          <p:cNvSpPr/>
+          <p:nvPr/>
+        </p:nvSpPr>
+        <p:spPr>
+          <a:xfrm>
+            <a:off x="558800" y="1371600"/>
+            <a:ext cx="7975600" cy="411480"/>
+          </a:xfrm>
+          <a:prstGeom prst="rect">
+            <a:avLst/>
+          </a:prstGeom>
+          <a:noFill/>
+          <a:ln/>
+        </p:spPr>
+        <p:txBody>
+          <a:bodyPr wrap="square" lIns="0" tIns="0" rIns="0" bIns="0" rtlCol="0" anchor="ctr"/>
+          <a:lstStyle/>
+          <a:p>
+            <a:pPr marL="0" indent="0">
+              <a:buNone/>
+            </a:pPr>
+            <a:r>
+              <a:rPr lang="en-US" sz="1400" b="1" dirty="0">
+                <a:solidFill>
+                  <a:srgbClr val="0B1F4B"/>
+                </a:solidFill>
+                <a:latin typeface="Avenir" pitchFamily="34" charset="0"/>
+                <a:ea typeface="Avenir" pitchFamily="34" charset="-122"/>
+                <a:cs typeface="Avenir" pitchFamily="34" charset="-120"/>
+              </a:rPr>
+              <a:t>{{SBU_1_NAME}}</a:t>
+            </a:r>
+            <a:endParaRPr lang="en-US" sz="1400" dirty="0"/>
+          </a:p>
+        </p:txBody>
+      </p:sp>
+      <p:sp>
+        <p:nvSpPr>
+          <p:cNvPr id="10" name="Text 8"/>
+          <p:cNvSpPr/>
+          <p:nvPr/>
+        </p:nvSpPr>
+        <p:spPr>
+          <a:xfrm>
+            <a:off x="558800" y="1879600"/>
+            <a:ext cx="7975600" cy="3048000"/>
+          </a:xfrm>
+          <a:prstGeom prst="rect">
+            <a:avLst/>
+          </a:prstGeom>
+          <a:noFill/>
+          <a:ln/>
+        </p:spPr>
+        <p:txBody>
+          <a:bodyPr wrap="square" lIns="0" tIns="0" rIns="0" bIns="0" rtlCol="0" anchor="ctr"/>
+          <a:lstStyle/>
+          <a:p>
+            <a:pPr marL="0" indent="0">
+              <a:lnSpc>
+                <a:spcPct val="140000"/>
+              </a:lnSpc>
+              <a:buNone/>
+            </a:pPr>
+            <a:r>
+              <a:rPr lang="en-US" sz="800" dirty="0">
+                <a:solidFill>
+                  <a:srgbClr val="1A1A2E"/>
+                </a:solidFill>
+                <a:latin typeface="Avenir" pitchFamily="34" charset="0"/>
+                <a:ea typeface="Avenir" pitchFamily="34" charset="-122"/>
+                <a:cs typeface="Avenir" pitchFamily="34" charset="-120"/>
+              </a:rPr>
+              <a:t>{{SBU_1_DESC}}</a:t>
+            </a:r>
+            <a:endParaRPr lang="en-US" sz="800" dirty="0"/>
+          </a:p>
+        </p:txBody>
+      </p:sp>
+    </p:spTree>
+    <p:extLst>
+      <p:ext uri="{BB962C8B-B14F-4D97-AF65-F5344CB8AC3E}">
+        <p14:creationId xmlns:p14="http://schemas.microsoft.com/office/powerpoint/2010/main" val="3211199787"/>
+      </p:ext>
+    </p:extLst>
+  </p:cSld>
+  <p:clrMapOvr>
+    <a:masterClrMapping/>
+  </p:clrMapOvr>
+</p:sld>
+</file>
+
+<file path=ppt/slides/slide5.xml><?xml version="1.0" encoding="utf-8"?>
+<p:sld xmlns:a="http://schemas.openxmlformats.org/drawingml/2006/main" xmlns:r="http://schemas.openxmlformats.org/officeDocument/2006/relationships" xmlns:p="http://schemas.openxmlformats.org/presentationml/2006/main">
+  <p:cSld name="Slide 3">
+    <p:bg>
+      <p:bgPr>
+        <a:solidFill>
+          <a:srgbClr val="F4F5F7"/>
+        </a:solidFill>
+        <a:effectLst/>
+      </p:bgPr>
+    </p:bg>
+    <p:spTree>
+      <p:nvGrpSpPr>
+        <p:cNvPr id="1" name=""/>
+        <p:cNvGrpSpPr/>
+        <p:nvPr/>
+      </p:nvGrpSpPr>
+      <p:grpSpPr>
+        <a:xfrm>
+          <a:off x="0" y="0"/>
+          <a:ext cx="0" cy="0"/>
+          <a:chOff x="0" y="0"/>
+          <a:chExt cx="0" cy="0"/>
+        </a:xfrm>
+      </p:grpSpPr>
+      <p:sp>
+        <p:nvSpPr>
+          <p:cNvPr id="2" name="Shape 0"/>
+          <p:cNvSpPr/>
+          <p:nvPr/>
+        </p:nvSpPr>
+        <p:spPr>
+          <a:xfrm>
+            <a:off x="0" y="0"/>
+            <a:ext cx="9144000" cy="914400"/>
+          </a:xfrm>
+          <a:prstGeom prst="rect">
             <a:avLst/>
           </a:prstGeom>
           <a:solidFill>
@@ -2354,50 +3475,46 @@
       </p:sp>
       <p:sp>
         <p:nvSpPr>
-          <p:cNvPr id="8" name="Text 6"/>
-          <p:cNvSpPr/>
-          <p:nvPr/>
-        </p:nvSpPr>
-        <p:spPr>
-          <a:xfrm>
-            <a:off x="584200" y="1371600"/>
-            <a:ext cx="502920" cy="502920"/>
-          </a:xfrm>
-          <a:prstGeom prst="rect">
-            <a:avLst/>
-          </a:prstGeom>
-          <a:noFill/>
-          <a:ln/>
-        </p:spPr>
-        <p:txBody>
-          <a:bodyPr wrap="square" lIns="0" tIns="0" rIns="0" bIns="0" rtlCol="0" anchor="ctr"/>
-          <a:lstStyle/>
-          <a:p>
-            <a:pPr marL="0" indent="0" algn="ctr">
-              <a:buNone/>
-            </a:pPr>
-            <a:r>
-              <a:rPr lang="en-US" sz="1800" dirty="0">
-                <a:solidFill>
-                  <a:srgbClr val="000000"/>
-                </a:solidFill>
-              </a:rPr>
-              <a:t>📻</a:t>
-            </a:r>
-            <a:endParaRPr lang="en-US" sz="1800" dirty="0"/>
-          </a:p>
-        </p:txBody>
-      </p:sp>
-      <p:sp>
-        <p:nvSpPr>
-          <p:cNvPr id="9" name="Text 7"/>
-          <p:cNvSpPr/>
-          <p:nvPr/>
-        </p:nvSpPr>
-        <p:spPr>
-          <a:xfrm>
-            <a:off x="558800" y="2011680"/>
-            <a:ext cx="2260600" cy="411480"/>
+          <p:cNvPr id="3" name="Shape 1"/>
+          <p:cNvSpPr/>
+          <p:nvPr/>
+        </p:nvSpPr>
+        <p:spPr>
+          <a:xfrm>
+            <a:off x="0" y="914400"/>
+            <a:ext cx="9144000" cy="54864"/>
+          </a:xfrm>
+          <a:prstGeom prst="rect">
+            <a:avLst/>
+          </a:prstGeom>
+          <a:solidFill>
+            <a:srgbClr val="C8102E"/>
+          </a:solidFill>
+          <a:ln w="12700">
+            <a:solidFill>
+              <a:srgbClr val="333333"/>
+            </a:solidFill>
+            <a:prstDash val="solid"/>
+          </a:ln>
+        </p:spPr>
+        <p:txBody>
+          <a:bodyPr/>
+          <a:lstStyle/>
+          <a:p>
+            <a:endParaRPr lang="en-US"/>
+          </a:p>
+        </p:txBody>
+      </p:sp>
+      <p:sp>
+        <p:nvSpPr>
+          <p:cNvPr id="4" name="Text 2"/>
+          <p:cNvSpPr/>
+          <p:nvPr/>
+        </p:nvSpPr>
+        <p:spPr>
+          <a:xfrm>
+            <a:off x="411480" y="0"/>
+            <a:ext cx="8321040" cy="914400"/>
           </a:xfrm>
           <a:prstGeom prst="rect">
             <a:avLst/>
@@ -2413,59 +3530,17 @@
               <a:buNone/>
             </a:pPr>
             <a:r>
-              <a:rPr lang="en-US" sz="1400" b="1" dirty="0">
-                <a:solidFill>
-                  <a:srgbClr val="0B1F4B"/>
+              <a:rPr lang="en-US" sz="1800" b="1" dirty="0">
+                <a:solidFill>
+                  <a:srgbClr val="FFFFFF"/>
                 </a:solidFill>
                 <a:latin typeface="Avenir" pitchFamily="34" charset="0"/>
                 <a:ea typeface="Avenir" pitchFamily="34" charset="-122"/>
                 <a:cs typeface="Avenir" pitchFamily="34" charset="-120"/>
               </a:rPr>
-              <a:t>{{SBU_1_NAME}}</a:t>
-            </a:r>
-            <a:endParaRPr lang="en-US" sz="1400" dirty="0"/>
-          </a:p>
-        </p:txBody>
-      </p:sp>
-      <p:sp>
-        <p:nvSpPr>
-          <p:cNvPr id="10" name="Text 8"/>
-          <p:cNvSpPr/>
-          <p:nvPr/>
-        </p:nvSpPr>
-        <p:spPr>
-          <a:xfrm>
-            <a:off x="558800" y="2487167"/>
-            <a:ext cx="2260600" cy="2452091"/>
-          </a:xfrm>
-          <a:prstGeom prst="rect">
-            <a:avLst/>
-          </a:prstGeom>
-          <a:noFill/>
-          <a:ln/>
-        </p:spPr>
-        <p:txBody>
-          <a:bodyPr wrap="square" lIns="0" tIns="0" rIns="0" bIns="0" rtlCol="0" anchor="ctr"/>
-          <a:lstStyle/>
-          <a:p>
-            <a:pPr marL="0" indent="0">
-              <a:lnSpc>
-                <a:spcPct val="140000"/>
-              </a:lnSpc>
-              <a:buNone/>
-            </a:pPr>
-            <a:r>
-              <a:rPr lang="en-US" sz="800" dirty="0">
-                <a:solidFill>
-                  <a:srgbClr val="1A1A2E"/>
-                </a:solidFill>
-                <a:latin typeface="Avenir" pitchFamily="34" charset="0"/>
-                <a:ea typeface="Avenir" pitchFamily="34" charset="-122"/>
-                <a:cs typeface="Avenir" pitchFamily="34" charset="-120"/>
-              </a:rPr>
-              <a:t>{{SBU_1_DESC}}</a:t>
-            </a:r>
-            <a:endParaRPr lang="en-US" sz="800" dirty="0"/>
+              <a:t>RECOMMENDED FOR {{CLIENT_NAME}}</a:t>
+            </a:r>
+            <a:endParaRPr lang="en-US" sz="1800" dirty="0"/>
           </a:p>
         </p:txBody>
       </p:sp>
@@ -2477,8 +3552,8 @@
         </p:nvSpPr>
         <p:spPr>
           <a:xfrm>
-            <a:off x="3276600" y="1188720"/>
-            <a:ext cx="2590800" cy="3832984"/>
+            <a:off x="419100" y="1188720"/>
+            <a:ext cx="8305800" cy="3832984"/>
           </a:xfrm>
           <a:prstGeom prst="rect">
             <a:avLst/>
@@ -2516,8 +3591,8 @@
         </p:nvSpPr>
         <p:spPr>
           <a:xfrm>
-            <a:off x="3276600" y="1188720"/>
-            <a:ext cx="2590800" cy="73152"/>
+            <a:off x="419100" y="1188720"/>
+            <a:ext cx="8305800" cy="73152"/>
           </a:xfrm>
           <a:prstGeom prst="rect">
             <a:avLst/>
@@ -2542,16 +3617,135 @@
       </p:sp>
       <p:sp>
         <p:nvSpPr>
-          <p:cNvPr id="14" name="Shape 12"/>
-          <p:cNvSpPr/>
-          <p:nvPr/>
-        </p:nvSpPr>
-        <p:spPr>
-          <a:xfrm>
-            <a:off x="3441700" y="1371600"/>
-            <a:ext cx="502920" cy="502920"/>
-          </a:xfrm>
-          <a:prstGeom prst="ellipse">
+          <p:cNvPr id="16" name="Text 14"/>
+          <p:cNvSpPr/>
+          <p:nvPr/>
+        </p:nvSpPr>
+        <p:spPr>
+          <a:xfrm>
+            <a:off x="558800" y="1371600"/>
+            <a:ext cx="7975600" cy="411480"/>
+          </a:xfrm>
+          <a:prstGeom prst="rect">
+            <a:avLst/>
+          </a:prstGeom>
+          <a:noFill/>
+          <a:ln/>
+        </p:spPr>
+        <p:txBody>
+          <a:bodyPr wrap="square" lIns="0" tIns="0" rIns="0" bIns="0" rtlCol="0" anchor="ctr"/>
+          <a:lstStyle/>
+          <a:p>
+            <a:pPr marL="0" indent="0">
+              <a:buNone/>
+            </a:pPr>
+            <a:r>
+              <a:rPr lang="en-US" sz="1400" b="1" dirty="0">
+                <a:solidFill>
+                  <a:srgbClr val="0B1F4B"/>
+                </a:solidFill>
+                <a:latin typeface="Avenir" pitchFamily="34" charset="0"/>
+                <a:ea typeface="Avenir" pitchFamily="34" charset="-122"/>
+                <a:cs typeface="Avenir" pitchFamily="34" charset="-120"/>
+              </a:rPr>
+              <a:t>{{SBU_2_NAME}}</a:t>
+            </a:r>
+            <a:endParaRPr lang="en-US" sz="1400" dirty="0"/>
+          </a:p>
+        </p:txBody>
+      </p:sp>
+      <p:sp>
+        <p:nvSpPr>
+          <p:cNvPr id="17" name="Text 15"/>
+          <p:cNvSpPr/>
+          <p:nvPr/>
+        </p:nvSpPr>
+        <p:spPr>
+          <a:xfrm>
+            <a:off x="558800" y="1879600"/>
+            <a:ext cx="7975600" cy="3048000"/>
+          </a:xfrm>
+          <a:prstGeom prst="rect">
+            <a:avLst/>
+          </a:prstGeom>
+          <a:noFill/>
+          <a:ln/>
+        </p:spPr>
+        <p:txBody>
+          <a:bodyPr wrap="square" lIns="0" tIns="0" rIns="0" bIns="0" rtlCol="0" anchor="ctr"/>
+          <a:lstStyle/>
+          <a:p>
+            <a:pPr marL="0" indent="0">
+              <a:lnSpc>
+                <a:spcPct val="140000"/>
+              </a:lnSpc>
+              <a:buNone/>
+            </a:pPr>
+            <a:r>
+              <a:rPr lang="en-US" sz="800" dirty="0">
+                <a:solidFill>
+                  <a:srgbClr val="1A1A2E"/>
+                </a:solidFill>
+                <a:latin typeface="Avenir" pitchFamily="34" charset="0"/>
+                <a:ea typeface="Avenir" pitchFamily="34" charset="-122"/>
+                <a:cs typeface="Avenir" pitchFamily="34" charset="-120"/>
+              </a:rPr>
+              <a:t>{{SBU_2_DESC}}</a:t>
+            </a:r>
+            <a:endParaRPr lang="en-US" sz="800" dirty="0"/>
+          </a:p>
+        </p:txBody>
+      </p:sp>
+    </p:spTree>
+    <p:extLst>
+      <p:ext uri="{BB962C8B-B14F-4D97-AF65-F5344CB8AC3E}">
+        <p14:creationId xmlns:p14="http://schemas.microsoft.com/office/powerpoint/2010/main" val="1724208400"/>
+      </p:ext>
+    </p:extLst>
+  </p:cSld>
+  <p:clrMapOvr>
+    <a:masterClrMapping/>
+  </p:clrMapOvr>
+</p:sld>
+</file>
+
+<file path=ppt/slides/slide6.xml><?xml version="1.0" encoding="utf-8"?>
+<p:sld xmlns:a="http://schemas.openxmlformats.org/drawingml/2006/main" xmlns:r="http://schemas.openxmlformats.org/officeDocument/2006/relationships" xmlns:p="http://schemas.openxmlformats.org/presentationml/2006/main">
+  <p:cSld name="Slide 3">
+    <p:bg>
+      <p:bgPr>
+        <a:solidFill>
+          <a:srgbClr val="F4F5F7"/>
+        </a:solidFill>
+        <a:effectLst/>
+      </p:bgPr>
+    </p:bg>
+    <p:spTree>
+      <p:nvGrpSpPr>
+        <p:cNvPr id="1" name=""/>
+        <p:cNvGrpSpPr/>
+        <p:nvPr/>
+      </p:nvGrpSpPr>
+      <p:grpSpPr>
+        <a:xfrm>
+          <a:off x="0" y="0"/>
+          <a:ext cx="0" cy="0"/>
+          <a:chOff x="0" y="0"/>
+          <a:chExt cx="0" cy="0"/>
+        </a:xfrm>
+      </p:grpSpPr>
+      <p:sp>
+        <p:nvSpPr>
+          <p:cNvPr id="2" name="Shape 0"/>
+          <p:cNvSpPr/>
+          <p:nvPr/>
+        </p:nvSpPr>
+        <p:spPr>
+          <a:xfrm>
+            <a:off x="0" y="0"/>
+            <a:ext cx="9144000" cy="914400"/>
+          </a:xfrm>
+          <a:prstGeom prst="rect">
             <a:avLst/>
           </a:prstGeom>
           <a:solidFill>
@@ -2574,50 +3768,46 @@
       </p:sp>
       <p:sp>
         <p:nvSpPr>
-          <p:cNvPr id="15" name="Text 13"/>
-          <p:cNvSpPr/>
-          <p:nvPr/>
-        </p:nvSpPr>
-        <p:spPr>
-          <a:xfrm>
-            <a:off x="3441700" y="1371600"/>
-            <a:ext cx="502920" cy="502920"/>
-          </a:xfrm>
-          <a:prstGeom prst="rect">
-            <a:avLst/>
-          </a:prstGeom>
-          <a:noFill/>
-          <a:ln/>
-        </p:spPr>
-        <p:txBody>
-          <a:bodyPr wrap="square" lIns="0" tIns="0" rIns="0" bIns="0" rtlCol="0" anchor="ctr"/>
-          <a:lstStyle/>
-          <a:p>
-            <a:pPr marL="0" indent="0" algn="ctr">
-              <a:buNone/>
-            </a:pPr>
-            <a:r>
-              <a:rPr lang="en-US" sz="1800" dirty="0">
-                <a:solidFill>
-                  <a:srgbClr val="000000"/>
-                </a:solidFill>
-              </a:rPr>
-              <a:t>💻</a:t>
-            </a:r>
-            <a:endParaRPr lang="en-US" sz="1800" dirty="0"/>
-          </a:p>
-        </p:txBody>
-      </p:sp>
-      <p:sp>
-        <p:nvSpPr>
-          <p:cNvPr id="16" name="Text 14"/>
-          <p:cNvSpPr/>
-          <p:nvPr/>
-        </p:nvSpPr>
-        <p:spPr>
-          <a:xfrm>
-            <a:off x="3416300" y="2011680"/>
-            <a:ext cx="2260600" cy="411480"/>
+          <p:cNvPr id="3" name="Shape 1"/>
+          <p:cNvSpPr/>
+          <p:nvPr/>
+        </p:nvSpPr>
+        <p:spPr>
+          <a:xfrm>
+            <a:off x="0" y="914400"/>
+            <a:ext cx="9144000" cy="54864"/>
+          </a:xfrm>
+          <a:prstGeom prst="rect">
+            <a:avLst/>
+          </a:prstGeom>
+          <a:solidFill>
+            <a:srgbClr val="C8102E"/>
+          </a:solidFill>
+          <a:ln w="12700">
+            <a:solidFill>
+              <a:srgbClr val="333333"/>
+            </a:solidFill>
+            <a:prstDash val="solid"/>
+          </a:ln>
+        </p:spPr>
+        <p:txBody>
+          <a:bodyPr/>
+          <a:lstStyle/>
+          <a:p>
+            <a:endParaRPr lang="en-US"/>
+          </a:p>
+        </p:txBody>
+      </p:sp>
+      <p:sp>
+        <p:nvSpPr>
+          <p:cNvPr id="4" name="Text 2"/>
+          <p:cNvSpPr/>
+          <p:nvPr/>
+        </p:nvSpPr>
+        <p:spPr>
+          <a:xfrm>
+            <a:off x="411480" y="0"/>
+            <a:ext cx="8321040" cy="914400"/>
           </a:xfrm>
           <a:prstGeom prst="rect">
             <a:avLst/>
@@ -2633,59 +3823,17 @@
               <a:buNone/>
             </a:pPr>
             <a:r>
-              <a:rPr lang="en-US" sz="1400" b="1" dirty="0">
-                <a:solidFill>
-                  <a:srgbClr val="0B1F4B"/>
+              <a:rPr lang="en-US" sz="1800" b="1" dirty="0">
+                <a:solidFill>
+                  <a:srgbClr val="FFFFFF"/>
                 </a:solidFill>
                 <a:latin typeface="Avenir" pitchFamily="34" charset="0"/>
                 <a:ea typeface="Avenir" pitchFamily="34" charset="-122"/>
                 <a:cs typeface="Avenir" pitchFamily="34" charset="-120"/>
               </a:rPr>
-              <a:t>{{SBU_2_NAME}}</a:t>
-            </a:r>
-            <a:endParaRPr lang="en-US" sz="1400" dirty="0"/>
-          </a:p>
-        </p:txBody>
-      </p:sp>
-      <p:sp>
-        <p:nvSpPr>
-          <p:cNvPr id="17" name="Text 15"/>
-          <p:cNvSpPr/>
-          <p:nvPr/>
-        </p:nvSpPr>
-        <p:spPr>
-          <a:xfrm>
-            <a:off x="3416300" y="2487168"/>
-            <a:ext cx="2260600" cy="2452090"/>
-          </a:xfrm>
-          <a:prstGeom prst="rect">
-            <a:avLst/>
-          </a:prstGeom>
-          <a:noFill/>
-          <a:ln/>
-        </p:spPr>
-        <p:txBody>
-          <a:bodyPr wrap="square" lIns="0" tIns="0" rIns="0" bIns="0" rtlCol="0" anchor="ctr"/>
-          <a:lstStyle/>
-          <a:p>
-            <a:pPr marL="0" indent="0">
-              <a:lnSpc>
-                <a:spcPct val="140000"/>
-              </a:lnSpc>
-              <a:buNone/>
-            </a:pPr>
-            <a:r>
-              <a:rPr lang="en-US" sz="800" dirty="0">
-                <a:solidFill>
-                  <a:srgbClr val="1A1A2E"/>
-                </a:solidFill>
-                <a:latin typeface="Avenir" pitchFamily="34" charset="0"/>
-                <a:ea typeface="Avenir" pitchFamily="34" charset="-122"/>
-                <a:cs typeface="Avenir" pitchFamily="34" charset="-120"/>
-              </a:rPr>
-              <a:t>{{SBU_2_DESC}}</a:t>
-            </a:r>
-            <a:endParaRPr lang="en-US" sz="800" dirty="0"/>
+              <a:t>RECOMMENDED FOR {{CLIENT_NAME}}</a:t>
+            </a:r>
+            <a:endParaRPr lang="en-US" sz="1800" dirty="0"/>
           </a:p>
         </p:txBody>
       </p:sp>
@@ -2697,8 +3845,8 @@
         </p:nvSpPr>
         <p:spPr>
           <a:xfrm>
-            <a:off x="6134100" y="1188720"/>
-            <a:ext cx="2590800" cy="3832984"/>
+            <a:off x="419100" y="1188720"/>
+            <a:ext cx="8305800" cy="3832984"/>
           </a:xfrm>
           <a:prstGeom prst="rect">
             <a:avLst/>
@@ -2736,8 +3884,8 @@
         </p:nvSpPr>
         <p:spPr>
           <a:xfrm>
-            <a:off x="6134100" y="1188720"/>
-            <a:ext cx="2590800" cy="73152"/>
+            <a:off x="419100" y="1188720"/>
+            <a:ext cx="8305800" cy="73152"/>
           </a:xfrm>
           <a:prstGeom prst="rect">
             <a:avLst/>
@@ -2762,82 +3910,14 @@
       </p:sp>
       <p:sp>
         <p:nvSpPr>
-          <p:cNvPr id="21" name="Shape 19"/>
-          <p:cNvSpPr/>
-          <p:nvPr/>
-        </p:nvSpPr>
-        <p:spPr>
-          <a:xfrm>
-            <a:off x="6299200" y="1371600"/>
-            <a:ext cx="502920" cy="502920"/>
-          </a:xfrm>
-          <a:prstGeom prst="ellipse">
-            <a:avLst/>
-          </a:prstGeom>
-          <a:solidFill>
-            <a:srgbClr val="0B1F4B"/>
-          </a:solidFill>
-          <a:ln w="12700">
-            <a:solidFill>
-              <a:srgbClr val="333333"/>
-            </a:solidFill>
-            <a:prstDash val="solid"/>
-          </a:ln>
-        </p:spPr>
-        <p:txBody>
-          <a:bodyPr/>
-          <a:lstStyle/>
-          <a:p>
-            <a:endParaRPr lang="en-US"/>
-          </a:p>
-        </p:txBody>
-      </p:sp>
-      <p:sp>
-        <p:nvSpPr>
-          <p:cNvPr id="22" name="Text 20"/>
-          <p:cNvSpPr/>
-          <p:nvPr/>
-        </p:nvSpPr>
-        <p:spPr>
-          <a:xfrm>
-            <a:off x="6299200" y="1371600"/>
-            <a:ext cx="502920" cy="502920"/>
-          </a:xfrm>
-          <a:prstGeom prst="rect">
-            <a:avLst/>
-          </a:prstGeom>
-          <a:noFill/>
-          <a:ln/>
-        </p:spPr>
-        <p:txBody>
-          <a:bodyPr wrap="square" lIns="0" tIns="0" rIns="0" bIns="0" rtlCol="0" anchor="ctr"/>
-          <a:lstStyle/>
-          <a:p>
-            <a:pPr marL="0" indent="0" algn="ctr">
-              <a:buNone/>
-            </a:pPr>
-            <a:r>
-              <a:rPr lang="en-US" sz="1800" dirty="0">
-                <a:solidFill>
-                  <a:srgbClr val="000000"/>
-                </a:solidFill>
-              </a:rPr>
-              <a:t>🎪</a:t>
-            </a:r>
-            <a:endParaRPr lang="en-US" sz="1800" dirty="0"/>
-          </a:p>
-        </p:txBody>
-      </p:sp>
-      <p:sp>
-        <p:nvSpPr>
           <p:cNvPr id="23" name="Text 21"/>
           <p:cNvSpPr/>
           <p:nvPr/>
         </p:nvSpPr>
         <p:spPr>
           <a:xfrm>
-            <a:off x="6273800" y="2011680"/>
-            <a:ext cx="2260600" cy="411480"/>
+            <a:off x="558800" y="1371600"/>
+            <a:ext cx="7975600" cy="411480"/>
           </a:xfrm>
           <a:prstGeom prst="rect">
             <a:avLst/>
@@ -2875,8 +3955,8 @@
         </p:nvSpPr>
         <p:spPr>
           <a:xfrm>
-            <a:off x="6273800" y="2487168"/>
-            <a:ext cx="2260600" cy="2452090"/>
+            <a:off x="558800" y="1879600"/>
+            <a:ext cx="7975600" cy="3048000"/>
           </a:xfrm>
           <a:prstGeom prst="rect">
             <a:avLst/>
@@ -2912,7 +3992,7 @@
     </p:spTree>
     <p:extLst>
       <p:ext uri="{BB962C8B-B14F-4D97-AF65-F5344CB8AC3E}">
-        <p14:creationId xmlns:p14="http://schemas.microsoft.com/office/powerpoint/2010/main" val="3211199787"/>
+        <p14:creationId xmlns:p14="http://schemas.microsoft.com/office/powerpoint/2010/main" val="1766875663"/>
       </p:ext>
     </p:extLst>
   </p:cSld>
@@ -2922,7 +4002,7 @@
 </p:sld>
 </file>
 
-<file path=ppt/slides/slide4.xml><?xml version="1.0" encoding="utf-8"?>
+<file path=ppt/slides/slide7.xml><?xml version="1.0" encoding="utf-8"?>
 <p:sld xmlns:a="http://schemas.openxmlformats.org/drawingml/2006/main" xmlns:r="http://schemas.openxmlformats.org/officeDocument/2006/relationships" xmlns:p="http://schemas.openxmlformats.org/presentationml/2006/main">
   <p:cSld name="Slide 4">
     <p:bg>
@@ -2949,70 +4029,6 @@
       </p:grpSpPr>
       <p:sp>
         <p:nvSpPr>
-          <p:cNvPr id="2" name="Shape 0"/>
-          <p:cNvSpPr/>
-          <p:nvPr/>
-        </p:nvSpPr>
-        <p:spPr>
-          <a:xfrm>
-            <a:off x="5303520" y="0"/>
-            <a:ext cx="3840480" cy="5143500"/>
-          </a:xfrm>
-          <a:prstGeom prst="rect">
-            <a:avLst/>
-          </a:prstGeom>
-          <a:solidFill>
-            <a:srgbClr val="1A1A2E"/>
-          </a:solidFill>
-          <a:ln w="12700">
-            <a:solidFill>
-              <a:srgbClr val="333333"/>
-            </a:solidFill>
-            <a:prstDash val="solid"/>
-          </a:ln>
-        </p:spPr>
-        <p:txBody>
-          <a:bodyPr/>
-          <a:lstStyle/>
-          <a:p>
-            <a:endParaRPr lang="en-US"/>
-          </a:p>
-        </p:txBody>
-      </p:sp>
-      <p:sp>
-        <p:nvSpPr>
-          <p:cNvPr id="3" name="Shape 1"/>
-          <p:cNvSpPr/>
-          <p:nvPr/>
-        </p:nvSpPr>
-        <p:spPr>
-          <a:xfrm>
-            <a:off x="5303520" y="0"/>
-            <a:ext cx="54864" cy="5143500"/>
-          </a:xfrm>
-          <a:prstGeom prst="rect">
-            <a:avLst/>
-          </a:prstGeom>
-          <a:solidFill>
-            <a:srgbClr val="E8A020"/>
-          </a:solidFill>
-          <a:ln w="12700">
-            <a:solidFill>
-              <a:srgbClr val="333333"/>
-            </a:solidFill>
-            <a:prstDash val="solid"/>
-          </a:ln>
-        </p:spPr>
-        <p:txBody>
-          <a:bodyPr/>
-          <a:lstStyle/>
-          <a:p>
-            <a:endParaRPr lang="en-US"/>
-          </a:p>
-        </p:txBody>
-      </p:sp>
-      <p:sp>
-        <p:nvSpPr>
           <p:cNvPr id="4" name="Text 2"/>
           <p:cNvSpPr/>
           <p:nvPr/>
@@ -3020,7 +4036,7 @@
         <p:spPr>
           <a:xfrm>
             <a:off x="411480" y="411480"/>
-            <a:ext cx="4572000" cy="274320"/>
+            <a:ext cx="8318500" cy="274320"/>
           </a:xfrm>
           <a:prstGeom prst="rect">
             <a:avLst/>
@@ -3059,7 +4075,7 @@
         <p:spPr>
           <a:xfrm>
             <a:off x="411480" y="777240"/>
-            <a:ext cx="4572000" cy="777240"/>
+            <a:ext cx="8318500" cy="777240"/>
           </a:xfrm>
           <a:prstGeom prst="rect">
             <a:avLst/>
@@ -3098,7 +4114,7 @@
         <p:spPr>
           <a:xfrm>
             <a:off x="411480" y="1394085"/>
-            <a:ext cx="4572000" cy="2029835"/>
+            <a:ext cx="8318500" cy="2029835"/>
           </a:xfrm>
           <a:prstGeom prst="rect">
             <a:avLst/>
@@ -3140,7 +4156,7 @@
         <p:spPr>
           <a:xfrm>
             <a:off x="411480" y="3429000"/>
-            <a:ext cx="4572000" cy="228600"/>
+            <a:ext cx="8318500" cy="228600"/>
           </a:xfrm>
           <a:prstGeom prst="rect">
             <a:avLst/>
@@ -3179,7 +4195,7 @@
         <p:spPr>
           <a:xfrm>
             <a:off x="411480" y="3749039"/>
-            <a:ext cx="4572000" cy="1302645"/>
+            <a:ext cx="8318500" cy="1302645"/>
           </a:xfrm>
           <a:prstGeom prst="rect">
             <a:avLst/>
@@ -3250,279 +4266,6 @@
                 <a:cs typeface="Avenir" pitchFamily="34" charset="-120"/>
               </a:rPr>
               <a:t>{{DELIVERABLE_3}}</a:t>
-            </a:r>
-            <a:endParaRPr lang="en-US" sz="800" dirty="0"/>
-          </a:p>
-        </p:txBody>
-      </p:sp>
-      <p:sp>
-        <p:nvSpPr>
-          <p:cNvPr id="9" name="Text 7"/>
-          <p:cNvSpPr/>
-          <p:nvPr/>
-        </p:nvSpPr>
-        <p:spPr>
-          <a:xfrm>
-            <a:off x="5577840" y="508000"/>
-            <a:ext cx="3291840" cy="274320"/>
-          </a:xfrm>
-          <a:prstGeom prst="rect">
-            <a:avLst/>
-          </a:prstGeom>
-          <a:noFill/>
-          <a:ln/>
-        </p:spPr>
-        <p:txBody>
-          <a:bodyPr wrap="square" lIns="0" tIns="0" rIns="0" bIns="0" rtlCol="0" anchor="ctr"/>
-          <a:lstStyle/>
-          <a:p>
-            <a:pPr marL="0" indent="0">
-              <a:buNone/>
-            </a:pPr>
-            <a:r>
-              <a:rPr lang="en-US" sz="900" b="1" kern="0" spc="300" dirty="0">
-                <a:solidFill>
-                  <a:srgbClr val="E8A020"/>
-                </a:solidFill>
-                <a:latin typeface="Avenir" pitchFamily="34" charset="0"/>
-                <a:ea typeface="Avenir" pitchFamily="34" charset="-122"/>
-                <a:cs typeface="Avenir" pitchFamily="34" charset="-120"/>
-              </a:rPr>
-              <a:t>PLATFORM MIX</a:t>
-            </a:r>
-            <a:endParaRPr lang="en-US" sz="900" dirty="0"/>
-          </a:p>
-        </p:txBody>
-      </p:sp>
-      <p:sp>
-        <p:nvSpPr>
-          <p:cNvPr id="10" name="Text 8"/>
-          <p:cNvSpPr/>
-          <p:nvPr/>
-        </p:nvSpPr>
-        <p:spPr>
-          <a:xfrm>
-            <a:off x="5577840" y="952500"/>
-            <a:ext cx="3291840" cy="274320"/>
-          </a:xfrm>
-          <a:prstGeom prst="rect">
-            <a:avLst/>
-          </a:prstGeom>
-          <a:noFill/>
-          <a:ln/>
-        </p:spPr>
-        <p:txBody>
-          <a:bodyPr wrap="square" lIns="0" tIns="0" rIns="0" bIns="0" rtlCol="0" anchor="ctr"/>
-          <a:lstStyle/>
-          <a:p>
-            <a:pPr marL="0" indent="0">
-              <a:buNone/>
-            </a:pPr>
-            <a:r>
-              <a:rPr lang="en-US" sz="1000" b="1" dirty="0">
-                <a:solidFill>
-                  <a:srgbClr val="FFFFFF"/>
-                </a:solidFill>
-                <a:latin typeface="Avenir" pitchFamily="34" charset="0"/>
-                <a:ea typeface="Avenir" pitchFamily="34" charset="-122"/>
-                <a:cs typeface="Avenir" pitchFamily="34" charset="-120"/>
-              </a:rPr>
-              <a:t>{{PLATFORM_1}}</a:t>
-            </a:r>
-            <a:endParaRPr lang="en-US" sz="1000" dirty="0"/>
-          </a:p>
-        </p:txBody>
-      </p:sp>
-      <p:sp>
-        <p:nvSpPr>
-          <p:cNvPr id="12" name="Text 10"/>
-          <p:cNvSpPr/>
-          <p:nvPr/>
-        </p:nvSpPr>
-        <p:spPr>
-          <a:xfrm>
-            <a:off x="5577840" y="1188720"/>
-            <a:ext cx="3017520" cy="843280"/>
-          </a:xfrm>
-          <a:prstGeom prst="rect">
-            <a:avLst/>
-          </a:prstGeom>
-          <a:noFill/>
-          <a:ln/>
-        </p:spPr>
-        <p:txBody>
-          <a:bodyPr wrap="square" lIns="0" tIns="0" rIns="0" bIns="0" rtlCol="0" anchor="ctr"/>
-          <a:lstStyle/>
-          <a:p>
-            <a:pPr marL="0" indent="0">
-              <a:buNone/>
-            </a:pPr>
-            <a:r>
-              <a:rPr lang="en-US" sz="800" dirty="0">
-                <a:solidFill>
-                  <a:srgbClr val="E8A020"/>
-                </a:solidFill>
-                <a:latin typeface="Avenir" pitchFamily="34" charset="0"/>
-                <a:ea typeface="Avenir" pitchFamily="34" charset="-122"/>
-                <a:cs typeface="Avenir" pitchFamily="34" charset="-120"/>
-              </a:rPr>
-              <a:t>{{PCT_1}}</a:t>
-            </a:r>
-            <a:endParaRPr lang="en-US" sz="800" dirty="0"/>
-          </a:p>
-        </p:txBody>
-      </p:sp>
-      <p:sp>
-        <p:nvSpPr>
-          <p:cNvPr id="13" name="Text 11"/>
-          <p:cNvSpPr/>
-          <p:nvPr/>
-        </p:nvSpPr>
-        <p:spPr>
-          <a:xfrm>
-            <a:off x="5577840" y="2032000"/>
-            <a:ext cx="3291840" cy="274320"/>
-          </a:xfrm>
-          <a:prstGeom prst="rect">
-            <a:avLst/>
-          </a:prstGeom>
-          <a:noFill/>
-          <a:ln/>
-        </p:spPr>
-        <p:txBody>
-          <a:bodyPr wrap="square" lIns="0" tIns="0" rIns="0" bIns="0" rtlCol="0" anchor="ctr"/>
-          <a:lstStyle/>
-          <a:p>
-            <a:pPr marL="0" indent="0">
-              <a:buNone/>
-            </a:pPr>
-            <a:r>
-              <a:rPr lang="en-US" sz="1000" b="1" dirty="0">
-                <a:solidFill>
-                  <a:srgbClr val="FFFFFF"/>
-                </a:solidFill>
-                <a:latin typeface="Avenir" pitchFamily="34" charset="0"/>
-                <a:ea typeface="Avenir" pitchFamily="34" charset="-122"/>
-                <a:cs typeface="Avenir" pitchFamily="34" charset="-120"/>
-              </a:rPr>
-              <a:t>{{PLATFORM_2}}</a:t>
-            </a:r>
-            <a:endParaRPr lang="en-US" sz="1000" dirty="0"/>
-          </a:p>
-        </p:txBody>
-      </p:sp>
-      <p:sp>
-        <p:nvSpPr>
-          <p:cNvPr id="15" name="Text 13"/>
-          <p:cNvSpPr/>
-          <p:nvPr/>
-        </p:nvSpPr>
-        <p:spPr>
-          <a:xfrm>
-            <a:off x="5577840" y="2306320"/>
-            <a:ext cx="3017520" cy="1117600"/>
-          </a:xfrm>
-          <a:prstGeom prst="rect">
-            <a:avLst/>
-          </a:prstGeom>
-          <a:noFill/>
-          <a:ln/>
-        </p:spPr>
-        <p:txBody>
-          <a:bodyPr wrap="square" lIns="0" tIns="0" rIns="0" bIns="0" rtlCol="0" anchor="ctr"/>
-          <a:lstStyle/>
-          <a:p>
-            <a:pPr marL="0" indent="0">
-              <a:buNone/>
-            </a:pPr>
-            <a:r>
-              <a:rPr lang="en-US" sz="800" dirty="0">
-                <a:solidFill>
-                  <a:srgbClr val="E8A020"/>
-                </a:solidFill>
-                <a:latin typeface="Avenir" pitchFamily="34" charset="0"/>
-                <a:ea typeface="Avenir" pitchFamily="34" charset="-122"/>
-                <a:cs typeface="Avenir" pitchFamily="34" charset="-120"/>
-              </a:rPr>
-              <a:t>{{PCT_2}}</a:t>
-            </a:r>
-            <a:endParaRPr lang="en-US" sz="800" dirty="0"/>
-          </a:p>
-        </p:txBody>
-      </p:sp>
-      <p:sp>
-        <p:nvSpPr>
-          <p:cNvPr id="16" name="Text 14"/>
-          <p:cNvSpPr/>
-          <p:nvPr/>
-        </p:nvSpPr>
-        <p:spPr>
-          <a:xfrm>
-            <a:off x="5577840" y="3429000"/>
-            <a:ext cx="3291840" cy="274320"/>
-          </a:xfrm>
-          <a:prstGeom prst="rect">
-            <a:avLst/>
-          </a:prstGeom>
-          <a:noFill/>
-          <a:ln/>
-        </p:spPr>
-        <p:txBody>
-          <a:bodyPr wrap="square" lIns="0" tIns="0" rIns="0" bIns="0" rtlCol="0" anchor="ctr"/>
-          <a:lstStyle/>
-          <a:p>
-            <a:pPr marL="0" indent="0">
-              <a:buNone/>
-            </a:pPr>
-            <a:r>
-              <a:rPr lang="en-US" sz="1000" b="1" dirty="0">
-                <a:solidFill>
-                  <a:srgbClr val="FFFFFF"/>
-                </a:solidFill>
-                <a:latin typeface="Avenir" pitchFamily="34" charset="0"/>
-                <a:ea typeface="Avenir" pitchFamily="34" charset="-122"/>
-                <a:cs typeface="Avenir" pitchFamily="34" charset="-120"/>
-              </a:rPr>
-              <a:t>{{PLATFORM_3}}</a:t>
-            </a:r>
-            <a:endParaRPr lang="en-US" sz="1000" dirty="0"/>
-          </a:p>
-        </p:txBody>
-      </p:sp>
-      <p:sp>
-        <p:nvSpPr>
-          <p:cNvPr id="18" name="Text 16"/>
-          <p:cNvSpPr/>
-          <p:nvPr/>
-        </p:nvSpPr>
-        <p:spPr>
-          <a:xfrm>
-            <a:off x="5577840" y="3708400"/>
-            <a:ext cx="3017520" cy="1117600"/>
-          </a:xfrm>
-          <a:prstGeom prst="rect">
-            <a:avLst/>
-          </a:prstGeom>
-          <a:noFill/>
-          <a:ln/>
-        </p:spPr>
-        <p:txBody>
-          <a:bodyPr wrap="square" lIns="0" tIns="0" rIns="0" bIns="0" rtlCol="0" anchor="ctr"/>
-          <a:lstStyle/>
-          <a:p>
-            <a:pPr marL="0" indent="0">
-              <a:buNone/>
-            </a:pPr>
-            <a:r>
-              <a:rPr lang="en-US" sz="800" dirty="0">
-                <a:solidFill>
-                  <a:srgbClr val="E8A020"/>
-                </a:solidFill>
-                <a:latin typeface="Avenir" pitchFamily="34" charset="0"/>
-                <a:ea typeface="Avenir" pitchFamily="34" charset="-122"/>
-                <a:cs typeface="Avenir" pitchFamily="34" charset="-120"/>
-              </a:rPr>
-              <a:t>{{PCT_3}}</a:t>
             </a:r>
             <a:endParaRPr lang="en-US" sz="800" dirty="0"/>
           </a:p>
@@ -3541,7 +4284,382 @@
 </p:sld>
 </file>
 
-<file path=ppt/slides/slide5.xml><?xml version="1.0" encoding="utf-8"?>
+<file path=ppt/slides/slide8.xml><?xml version="1.0" encoding="utf-8"?>
+<p:sld xmlns:a="http://schemas.openxmlformats.org/drawingml/2006/main" xmlns:r="http://schemas.openxmlformats.org/officeDocument/2006/relationships" xmlns:p="http://schemas.openxmlformats.org/presentationml/2006/main">
+  <p:cSld name="Slide 4">
+    <p:bg>
+      <p:bgPr>
+        <a:solidFill>
+          <a:srgbClr val="FFFFFF"/>
+        </a:solidFill>
+        <a:effectLst/>
+      </p:bgPr>
+    </p:bg>
+    <p:spTree>
+      <p:nvGrpSpPr>
+        <p:cNvPr id="1" name=""/>
+        <p:cNvGrpSpPr/>
+        <p:nvPr/>
+      </p:nvGrpSpPr>
+      <p:grpSpPr>
+        <a:xfrm>
+          <a:off x="0" y="0"/>
+          <a:ext cx="0" cy="0"/>
+          <a:chOff x="0" y="0"/>
+          <a:chExt cx="0" cy="0"/>
+        </a:xfrm>
+      </p:grpSpPr>
+      <p:sp>
+        <p:nvSpPr>
+          <p:cNvPr id="2" name="Shape 0"/>
+          <p:cNvSpPr/>
+          <p:nvPr/>
+        </p:nvSpPr>
+        <p:spPr>
+          <a:xfrm>
+            <a:off x="0" y="0"/>
+            <a:ext cx="9144000" cy="5143500"/>
+          </a:xfrm>
+          <a:prstGeom prst="rect">
+            <a:avLst/>
+          </a:prstGeom>
+          <a:solidFill>
+            <a:srgbClr val="1A1A2E"/>
+          </a:solidFill>
+          <a:ln w="12700">
+            <a:solidFill>
+              <a:srgbClr val="333333"/>
+            </a:solidFill>
+            <a:prstDash val="solid"/>
+          </a:ln>
+        </p:spPr>
+        <p:txBody>
+          <a:bodyPr/>
+          <a:lstStyle/>
+          <a:p>
+            <a:endParaRPr lang="en-US"/>
+          </a:p>
+        </p:txBody>
+      </p:sp>
+      <p:sp>
+        <p:nvSpPr>
+          <p:cNvPr id="3" name="Shape 1"/>
+          <p:cNvSpPr/>
+          <p:nvPr/>
+        </p:nvSpPr>
+        <p:spPr>
+          <a:xfrm>
+            <a:off x="0" y="0"/>
+            <a:ext cx="54864" cy="5143500"/>
+          </a:xfrm>
+          <a:prstGeom prst="rect">
+            <a:avLst/>
+          </a:prstGeom>
+          <a:solidFill>
+            <a:srgbClr val="E8A020"/>
+          </a:solidFill>
+          <a:ln w="12700">
+            <a:solidFill>
+              <a:srgbClr val="333333"/>
+            </a:solidFill>
+            <a:prstDash val="solid"/>
+          </a:ln>
+        </p:spPr>
+        <p:txBody>
+          <a:bodyPr/>
+          <a:lstStyle/>
+          <a:p>
+            <a:endParaRPr lang="en-US"/>
+          </a:p>
+        </p:txBody>
+      </p:sp>
+      <p:sp>
+        <p:nvSpPr>
+          <p:cNvPr id="9" name="Text 7"/>
+          <p:cNvSpPr/>
+          <p:nvPr/>
+        </p:nvSpPr>
+        <p:spPr>
+          <a:xfrm>
+            <a:off x="406400" y="508000"/>
+            <a:ext cx="8318500" cy="274320"/>
+          </a:xfrm>
+          <a:prstGeom prst="rect">
+            <a:avLst/>
+          </a:prstGeom>
+          <a:noFill/>
+          <a:ln/>
+        </p:spPr>
+        <p:txBody>
+          <a:bodyPr wrap="square" lIns="0" tIns="0" rIns="0" bIns="0" rtlCol="0" anchor="ctr"/>
+          <a:lstStyle/>
+          <a:p>
+            <a:pPr marL="0" indent="0">
+              <a:buNone/>
+            </a:pPr>
+            <a:r>
+              <a:rPr lang="en-US" sz="900" b="1" kern="0" spc="300" dirty="0">
+                <a:solidFill>
+                  <a:srgbClr val="E8A020"/>
+                </a:solidFill>
+                <a:latin typeface="Avenir" pitchFamily="34" charset="0"/>
+                <a:ea typeface="Avenir" pitchFamily="34" charset="-122"/>
+                <a:cs typeface="Avenir" pitchFamily="34" charset="-120"/>
+              </a:rPr>
+              <a:t>PLATFORM MIX</a:t>
+            </a:r>
+            <a:endParaRPr lang="en-US" sz="900" dirty="0"/>
+          </a:p>
+        </p:txBody>
+      </p:sp>
+      <p:sp>
+        <p:nvSpPr>
+          <p:cNvPr id="10" name="Text 8"/>
+          <p:cNvSpPr/>
+          <p:nvPr/>
+        </p:nvSpPr>
+        <p:spPr>
+          <a:xfrm>
+            <a:off x="406400" y="952500"/>
+            <a:ext cx="8318500" cy="274320"/>
+          </a:xfrm>
+          <a:prstGeom prst="rect">
+            <a:avLst/>
+          </a:prstGeom>
+          <a:noFill/>
+          <a:ln/>
+        </p:spPr>
+        <p:txBody>
+          <a:bodyPr wrap="square" lIns="0" tIns="0" rIns="0" bIns="0" rtlCol="0" anchor="ctr"/>
+          <a:lstStyle/>
+          <a:p>
+            <a:pPr marL="0" indent="0">
+              <a:buNone/>
+            </a:pPr>
+            <a:r>
+              <a:rPr lang="en-US" sz="1000" b="1" dirty="0">
+                <a:solidFill>
+                  <a:srgbClr val="FFFFFF"/>
+                </a:solidFill>
+                <a:latin typeface="Avenir" pitchFamily="34" charset="0"/>
+                <a:ea typeface="Avenir" pitchFamily="34" charset="-122"/>
+                <a:cs typeface="Avenir" pitchFamily="34" charset="-120"/>
+              </a:rPr>
+              <a:t>{{PLATFORM_1}}</a:t>
+            </a:r>
+            <a:endParaRPr lang="en-US" sz="1000" dirty="0"/>
+          </a:p>
+        </p:txBody>
+      </p:sp>
+      <p:sp>
+        <p:nvSpPr>
+          <p:cNvPr id="12" name="Text 10"/>
+          <p:cNvSpPr/>
+          <p:nvPr/>
+        </p:nvSpPr>
+        <p:spPr>
+          <a:xfrm>
+            <a:off x="406400" y="1188720"/>
+            <a:ext cx="8318500" cy="843280"/>
+          </a:xfrm>
+          <a:prstGeom prst="rect">
+            <a:avLst/>
+          </a:prstGeom>
+          <a:noFill/>
+          <a:ln/>
+        </p:spPr>
+        <p:txBody>
+          <a:bodyPr wrap="square" lIns="0" tIns="0" rIns="0" bIns="0" rtlCol="0" anchor="ctr"/>
+          <a:lstStyle/>
+          <a:p>
+            <a:pPr marL="0" indent="0">
+              <a:buNone/>
+            </a:pPr>
+            <a:r>
+              <a:rPr lang="en-US" sz="800" dirty="0">
+                <a:solidFill>
+                  <a:srgbClr val="E8A020"/>
+                </a:solidFill>
+                <a:latin typeface="Avenir" pitchFamily="34" charset="0"/>
+                <a:ea typeface="Avenir" pitchFamily="34" charset="-122"/>
+                <a:cs typeface="Avenir" pitchFamily="34" charset="-120"/>
+              </a:rPr>
+              <a:t>{{PCT_1}}</a:t>
+            </a:r>
+            <a:endParaRPr lang="en-US" sz="800" dirty="0"/>
+          </a:p>
+        </p:txBody>
+      </p:sp>
+      <p:sp>
+        <p:nvSpPr>
+          <p:cNvPr id="13" name="Text 11"/>
+          <p:cNvSpPr/>
+          <p:nvPr/>
+        </p:nvSpPr>
+        <p:spPr>
+          <a:xfrm>
+            <a:off x="406400" y="2032000"/>
+            <a:ext cx="8318500" cy="274320"/>
+          </a:xfrm>
+          <a:prstGeom prst="rect">
+            <a:avLst/>
+          </a:prstGeom>
+          <a:noFill/>
+          <a:ln/>
+        </p:spPr>
+        <p:txBody>
+          <a:bodyPr wrap="square" lIns="0" tIns="0" rIns="0" bIns="0" rtlCol="0" anchor="ctr"/>
+          <a:lstStyle/>
+          <a:p>
+            <a:pPr marL="0" indent="0">
+              <a:buNone/>
+            </a:pPr>
+            <a:r>
+              <a:rPr lang="en-US" sz="1000" b="1" dirty="0">
+                <a:solidFill>
+                  <a:srgbClr val="FFFFFF"/>
+                </a:solidFill>
+                <a:latin typeface="Avenir" pitchFamily="34" charset="0"/>
+                <a:ea typeface="Avenir" pitchFamily="34" charset="-122"/>
+                <a:cs typeface="Avenir" pitchFamily="34" charset="-120"/>
+              </a:rPr>
+              <a:t>{{PLATFORM_2}}</a:t>
+            </a:r>
+            <a:endParaRPr lang="en-US" sz="1000" dirty="0"/>
+          </a:p>
+        </p:txBody>
+      </p:sp>
+      <p:sp>
+        <p:nvSpPr>
+          <p:cNvPr id="15" name="Text 13"/>
+          <p:cNvSpPr/>
+          <p:nvPr/>
+        </p:nvSpPr>
+        <p:spPr>
+          <a:xfrm>
+            <a:off x="406400" y="2306320"/>
+            <a:ext cx="8318500" cy="1117600"/>
+          </a:xfrm>
+          <a:prstGeom prst="rect">
+            <a:avLst/>
+          </a:prstGeom>
+          <a:noFill/>
+          <a:ln/>
+        </p:spPr>
+        <p:txBody>
+          <a:bodyPr wrap="square" lIns="0" tIns="0" rIns="0" bIns="0" rtlCol="0" anchor="ctr"/>
+          <a:lstStyle/>
+          <a:p>
+            <a:pPr marL="0" indent="0">
+              <a:buNone/>
+            </a:pPr>
+            <a:r>
+              <a:rPr lang="en-US" sz="800" dirty="0">
+                <a:solidFill>
+                  <a:srgbClr val="E8A020"/>
+                </a:solidFill>
+                <a:latin typeface="Avenir" pitchFamily="34" charset="0"/>
+                <a:ea typeface="Avenir" pitchFamily="34" charset="-122"/>
+                <a:cs typeface="Avenir" pitchFamily="34" charset="-120"/>
+              </a:rPr>
+              <a:t>{{PCT_2}}</a:t>
+            </a:r>
+            <a:endParaRPr lang="en-US" sz="800" dirty="0"/>
+          </a:p>
+        </p:txBody>
+      </p:sp>
+      <p:sp>
+        <p:nvSpPr>
+          <p:cNvPr id="16" name="Text 14"/>
+          <p:cNvSpPr/>
+          <p:nvPr/>
+        </p:nvSpPr>
+        <p:spPr>
+          <a:xfrm>
+            <a:off x="406400" y="3429000"/>
+            <a:ext cx="8318500" cy="274320"/>
+          </a:xfrm>
+          <a:prstGeom prst="rect">
+            <a:avLst/>
+          </a:prstGeom>
+          <a:noFill/>
+          <a:ln/>
+        </p:spPr>
+        <p:txBody>
+          <a:bodyPr wrap="square" lIns="0" tIns="0" rIns="0" bIns="0" rtlCol="0" anchor="ctr"/>
+          <a:lstStyle/>
+          <a:p>
+            <a:pPr marL="0" indent="0">
+              <a:buNone/>
+            </a:pPr>
+            <a:r>
+              <a:rPr lang="en-US" sz="1000" b="1" dirty="0">
+                <a:solidFill>
+                  <a:srgbClr val="FFFFFF"/>
+                </a:solidFill>
+                <a:latin typeface="Avenir" pitchFamily="34" charset="0"/>
+                <a:ea typeface="Avenir" pitchFamily="34" charset="-122"/>
+                <a:cs typeface="Avenir" pitchFamily="34" charset="-120"/>
+              </a:rPr>
+              <a:t>{{PLATFORM_3}}</a:t>
+            </a:r>
+            <a:endParaRPr lang="en-US" sz="1000" dirty="0"/>
+          </a:p>
+        </p:txBody>
+      </p:sp>
+      <p:sp>
+        <p:nvSpPr>
+          <p:cNvPr id="18" name="Text 16"/>
+          <p:cNvSpPr/>
+          <p:nvPr/>
+        </p:nvSpPr>
+        <p:spPr>
+          <a:xfrm>
+            <a:off x="406400" y="3708400"/>
+            <a:ext cx="8318500" cy="1117600"/>
+          </a:xfrm>
+          <a:prstGeom prst="rect">
+            <a:avLst/>
+          </a:prstGeom>
+          <a:noFill/>
+          <a:ln/>
+        </p:spPr>
+        <p:txBody>
+          <a:bodyPr wrap="square" lIns="0" tIns="0" rIns="0" bIns="0" rtlCol="0" anchor="ctr"/>
+          <a:lstStyle/>
+          <a:p>
+            <a:pPr marL="0" indent="0">
+              <a:buNone/>
+            </a:pPr>
+            <a:r>
+              <a:rPr lang="en-US" sz="800" dirty="0">
+                <a:solidFill>
+                  <a:srgbClr val="E8A020"/>
+                </a:solidFill>
+                <a:latin typeface="Avenir" pitchFamily="34" charset="0"/>
+                <a:ea typeface="Avenir" pitchFamily="34" charset="-122"/>
+                <a:cs typeface="Avenir" pitchFamily="34" charset="-120"/>
+              </a:rPr>
+              <a:t>{{PCT_3}}</a:t>
+            </a:r>
+            <a:endParaRPr lang="en-US" sz="800" dirty="0"/>
+          </a:p>
+        </p:txBody>
+      </p:sp>
+    </p:spTree>
+    <p:extLst>
+      <p:ext uri="{BB962C8B-B14F-4D97-AF65-F5344CB8AC3E}">
+        <p14:creationId xmlns:p14="http://schemas.microsoft.com/office/powerpoint/2010/main" val="2336523692"/>
+      </p:ext>
+    </p:extLst>
+  </p:cSld>
+  <p:clrMapOvr>
+    <a:masterClrMapping/>
+  </p:clrMapOvr>
+</p:sld>
+</file>
+
+<file path=ppt/slides/slide9.xml><?xml version="1.0" encoding="utf-8"?>
 <p:sld xmlns:a="http://schemas.openxmlformats.org/drawingml/2006/main" xmlns:r="http://schemas.openxmlformats.org/officeDocument/2006/relationships" xmlns:p="http://schemas.openxmlformats.org/presentationml/2006/main">
   <p:cSld name="Slide 5">
     <p:bg>
@@ -3899,38 +5017,38 @@
 </file>
 
 <file path=ppt/theme/theme1.xml><?xml version="1.0" encoding="utf-8"?>
-<a:theme xmlns:a="http://schemas.openxmlformats.org/drawingml/2006/main" name="Office Theme [1777012686762]">
+<a:theme xmlns:a="http://schemas.openxmlformats.org/drawingml/2006/main" name="Office Theme [1777273131338]">
   <a:themeElements>
     <a:clrScheme name="Office">
       <a:dk1>
-        <a:sysClr val="windowText" lastClr="000000"/>
+        <a:srgbClr val="1A1A2E"/>
       </a:dk1>
       <a:lt1>
-        <a:sysClr val="window" lastClr="FFFFFF"/>
+        <a:srgbClr val="FFFFFF"/>
       </a:lt1>
       <a:dk2>
-        <a:srgbClr val="44546A"/>
+        <a:srgbClr val="3D3D5C"/>
       </a:dk2>
       <a:lt2>
-        <a:srgbClr val="E7E6E6"/>
+        <a:srgbClr val="F5F5F7"/>
       </a:lt2>
       <a:accent1>
-        <a:srgbClr val="4472C4"/>
+        <a:srgbClr val="0B1F4B"/>
       </a:accent1>
       <a:accent2>
-        <a:srgbClr val="ED7D31"/>
+        <a:srgbClr val="D4A843"/>
       </a:accent2>
       <a:accent3>
-        <a:srgbClr val="A5A5A5"/>
+        <a:srgbClr val="E8E8EC"/>
       </a:accent3>
       <a:accent4>
-        <a:srgbClr val="FFC000"/>
+        <a:srgbClr val="C8102E"/>
       </a:accent4>
       <a:accent5>
-        <a:srgbClr val="5B9BD5"/>
+        <a:srgbClr val="5A7DA8"/>
       </a:accent5>
       <a:accent6>
-        <a:srgbClr val="70AD47"/>
+        <a:srgbClr val="2D6A4F"/>
       </a:accent6>
       <a:hlink>
         <a:srgbClr val="0563C1"/>
@@ -3941,7 +5059,7 @@
     </a:clrScheme>
     <a:fontScheme name="Office">
       <a:majorFont>
-        <a:latin typeface="Avenir" panose="020F0302020204030204"/>
+        <a:latin typeface="Montserrat" panose="020F0302020204030204"/>
         <a:ea typeface=""/>
         <a:cs typeface=""/>
         <a:font script="Jpan" typeface="游ゴシック Light"/>
@@ -3993,7 +5111,7 @@
         <a:font script="Tfng" typeface="Ebrima"/>
       </a:majorFont>
       <a:minorFont>
-        <a:latin typeface="Avenir" panose="020F0502020204030204"/>
+        <a:latin typeface="Source Sans Pro" panose="020F0502020204030204"/>
         <a:ea typeface=""/>
         <a:cs typeface=""/>
         <a:font script="Jpan" typeface="游ゴシック"/>

</xml_diff>

<commit_message>
Fix mobile layout: responsive grid, reduced padding, stacked SalesRep fields on small screens
Co-Authored-By: Claude Sonnet 4.6 <noreply@anthropic.com>
</commit_message>
<xml_diff>
--- a/master-deck/MBC_MASTER_DECK.pptx
+++ b/master-deck/MBC_MASTER_DECK.pptx
@@ -14,8 +14,8 @@
     <p:sldId id="264" r:id="rId5"/>
     <p:sldId id="272" r:id="rId6"/>
     <p:sldId id="271" r:id="rId7"/>
-    <p:sldId id="265" r:id="rId8"/>
-    <p:sldId id="273" r:id="rId9"/>
+    <p:sldId id="276" r:id="rId8"/>
+    <p:sldId id="277" r:id="rId9"/>
     <p:sldId id="266" r:id="rId10"/>
   </p:sldIdLst>
   <p:sldSz cx="9144000" cy="5143500" type="screen16x9"/>
@@ -2102,7 +2102,7 @@
               <a:buNone/>
             </a:pPr>
             <a:r>
-              <a:rPr lang="en-US" sz="1100" b="1" kern="0" spc="300" dirty="0">
+              <a:rPr lang="en-US" sz="1400" b="1" kern="0" spc="300" dirty="0">
                 <a:solidFill>
                   <a:srgbClr val="C8102E"/>
                 </a:solidFill>
@@ -2112,7 +2112,7 @@
               </a:rPr>
               <a:t>YOUR INTEGRATED MEDIA PARTNER</a:t>
             </a:r>
-            <a:endParaRPr lang="en-US" sz="1100" dirty="0"/>
+            <a:endParaRPr lang="en-US" sz="1400" dirty="0"/>
           </a:p>
         </p:txBody>
       </p:sp>
@@ -2144,7 +2144,7 @@
               <a:buNone/>
             </a:pPr>
             <a:r>
-              <a:rPr lang="en-US" sz="800" dirty="0">
+              <a:rPr lang="en-US" sz="1050" dirty="0">
                 <a:solidFill>
                   <a:srgbClr val="1A1A2E"/>
                 </a:solidFill>
@@ -2154,7 +2154,7 @@
               </a:rPr>
               <a:t>{{CLIENT_INTRO}}</a:t>
             </a:r>
-            <a:endParaRPr lang="en-US" sz="800" dirty="0"/>
+            <a:endParaRPr lang="en-US" sz="1050" dirty="0"/>
           </a:p>
         </p:txBody>
       </p:sp>
@@ -2960,7 +2960,7 @@
               <a:buNone/>
             </a:pPr>
             <a:r>
-              <a:rPr lang="en-US" sz="800" dirty="0">
+              <a:rPr lang="en-US" sz="1000" dirty="0">
                 <a:solidFill>
                   <a:srgbClr val="1A1A2E"/>
                 </a:solidFill>
@@ -2970,7 +2970,7 @@
               </a:rPr>
               <a:t>{{CLIENT_WHY}}</a:t>
             </a:r>
-            <a:endParaRPr lang="en-US" sz="800" dirty="0"/>
+            <a:endParaRPr lang="en-US" sz="1000" dirty="0"/>
           </a:p>
         </p:txBody>
       </p:sp>
@@ -3389,7 +3389,7 @@
               <a:buNone/>
             </a:pPr>
             <a:r>
-              <a:rPr lang="en-US" sz="800" dirty="0">
+              <a:rPr lang="en-US" sz="1200" dirty="0">
                 <a:solidFill>
                   <a:srgbClr val="1A1A2E"/>
                 </a:solidFill>
@@ -3399,7 +3399,7 @@
               </a:rPr>
               <a:t>{{SBU_1_DESC}}</a:t>
             </a:r>
-            <a:endParaRPr lang="en-US" sz="800" dirty="0"/>
+            <a:endParaRPr lang="en-US" sz="1200" dirty="0"/>
           </a:p>
         </p:txBody>
       </p:sp>
@@ -3682,7 +3682,7 @@
               <a:buNone/>
             </a:pPr>
             <a:r>
-              <a:rPr lang="en-US" sz="800" dirty="0">
+              <a:rPr lang="en-US" sz="1200" dirty="0">
                 <a:solidFill>
                   <a:srgbClr val="1A1A2E"/>
                 </a:solidFill>
@@ -3692,7 +3692,7 @@
               </a:rPr>
               <a:t>{{SBU_2_DESC}}</a:t>
             </a:r>
-            <a:endParaRPr lang="en-US" sz="800" dirty="0"/>
+            <a:endParaRPr lang="en-US" sz="1200" dirty="0"/>
           </a:p>
         </p:txBody>
       </p:sp>
@@ -3975,7 +3975,7 @@
               <a:buNone/>
             </a:pPr>
             <a:r>
-              <a:rPr lang="en-US" sz="800" dirty="0">
+              <a:rPr lang="en-US" sz="1200" dirty="0">
                 <a:solidFill>
                   <a:srgbClr val="1A1A2E"/>
                 </a:solidFill>
@@ -3985,7 +3985,7 @@
               </a:rPr>
               <a:t>{{SBU_3_DESC}}</a:t>
             </a:r>
-            <a:endParaRPr lang="en-US" sz="800" dirty="0"/>
+            <a:endParaRPr lang="en-US" sz="1200" dirty="0"/>
           </a:p>
         </p:txBody>
       </p:sp>
@@ -4029,6 +4029,60 @@
       </p:grpSpPr>
       <p:sp>
         <p:nvSpPr>
+          <p:cNvPr id="2" name="Rounded Rectangle 1">
+            <a:extLst>
+              <a:ext uri="{FF2B5EF4-FFF2-40B4-BE49-F238E27FC236}">
+                <a16:creationId xmlns:a16="http://schemas.microsoft.com/office/drawing/2014/main" id="{E0C31EDE-89C3-E94D-8172-DBFC55FB9F16}"/>
+              </a:ext>
+            </a:extLst>
+          </p:cNvPr>
+          <p:cNvSpPr/>
+          <p:nvPr/>
+        </p:nvSpPr>
+        <p:spPr>
+          <a:xfrm>
+            <a:off x="5016500" y="406400"/>
+            <a:ext cx="3721100" cy="4419600"/>
+          </a:xfrm>
+          <a:prstGeom prst="roundRect">
+            <a:avLst/>
+          </a:prstGeom>
+          <a:solidFill>
+            <a:srgbClr val="0B1F4B"/>
+          </a:solidFill>
+          <a:ln w="12700" cap="flat" cmpd="sng" algn="ctr">
+            <a:noFill/>
+            <a:prstDash val="solid"/>
+            <a:miter lim="800000"/>
+          </a:ln>
+        </p:spPr>
+        <p:style>
+          <a:lnRef idx="2">
+            <a:schemeClr val="accent1">
+              <a:shade val="15000"/>
+            </a:schemeClr>
+          </a:lnRef>
+          <a:fillRef idx="1">
+            <a:schemeClr val="accent1"/>
+          </a:fillRef>
+          <a:effectRef idx="0">
+            <a:schemeClr val="accent1"/>
+          </a:effectRef>
+          <a:fontRef idx="minor">
+            <a:schemeClr val="lt1"/>
+          </a:fontRef>
+        </p:style>
+        <p:txBody>
+          <a:bodyPr vertOverflow="clip" horzOverflow="clip" rtlCol="0" anchor="t"/>
+          <a:lstStyle/>
+          <a:p>
+            <a:pPr algn="l"/>
+            <a:endParaRPr lang="en-US"/>
+          </a:p>
+        </p:txBody>
+      </p:sp>
+      <p:sp>
+        <p:nvSpPr>
           <p:cNvPr id="4" name="Text 2"/>
           <p:cNvSpPr/>
           <p:nvPr/>
@@ -4036,7 +4090,7 @@
         <p:spPr>
           <a:xfrm>
             <a:off x="411480" y="411480"/>
-            <a:ext cx="8318500" cy="274320"/>
+            <a:ext cx="4445000" cy="274320"/>
           </a:xfrm>
           <a:prstGeom prst="rect">
             <a:avLst/>
@@ -4075,7 +4129,7 @@
         <p:spPr>
           <a:xfrm>
             <a:off x="411480" y="777240"/>
-            <a:ext cx="8318500" cy="777240"/>
+            <a:ext cx="4445000" cy="777240"/>
           </a:xfrm>
           <a:prstGeom prst="rect">
             <a:avLst/>
@@ -4113,8 +4167,8 @@
         </p:nvSpPr>
         <p:spPr>
           <a:xfrm>
-            <a:off x="411480" y="1394085"/>
-            <a:ext cx="8318500" cy="2029835"/>
+            <a:off x="411480" y="1574800"/>
+            <a:ext cx="4445000" cy="1656413"/>
           </a:xfrm>
           <a:prstGeom prst="rect">
             <a:avLst/>
@@ -4133,7 +4187,7 @@
               <a:buNone/>
             </a:pPr>
             <a:r>
-              <a:rPr lang="en-US" sz="800" dirty="0">
+              <a:rPr lang="en-US" sz="1000" dirty="0">
                 <a:solidFill>
                   <a:srgbClr val="1A1A2E"/>
                 </a:solidFill>
@@ -4143,7 +4197,7 @@
               </a:rPr>
               <a:t>{{CAMPAIGN_DESC}}</a:t>
             </a:r>
-            <a:endParaRPr lang="en-US" sz="800" dirty="0"/>
+            <a:endParaRPr lang="en-US" sz="1000" dirty="0"/>
           </a:p>
         </p:txBody>
       </p:sp>
@@ -4155,8 +4209,8 @@
         </p:nvSpPr>
         <p:spPr>
           <a:xfrm>
-            <a:off x="411480" y="3429000"/>
-            <a:ext cx="8318500" cy="228600"/>
+            <a:off x="5334000" y="660400"/>
+            <a:ext cx="3149600" cy="228600"/>
           </a:xfrm>
           <a:prstGeom prst="rect">
             <a:avLst/>
@@ -4168,13 +4222,13 @@
           <a:bodyPr wrap="square" lIns="0" tIns="0" rIns="0" bIns="0" rtlCol="0" anchor="ctr"/>
           <a:lstStyle/>
           <a:p>
-            <a:pPr marL="0" indent="0">
+            <a:pPr marL="0" indent="0" algn="ctr">
               <a:buNone/>
             </a:pPr>
             <a:r>
               <a:rPr lang="en-US" sz="800" b="1" kern="0" spc="300" dirty="0">
                 <a:solidFill>
-                  <a:srgbClr val="7A8090"/>
+                  <a:srgbClr val="D4A843"/>
                 </a:solidFill>
                 <a:latin typeface="Avenir" pitchFamily="34" charset="0"/>
                 <a:ea typeface="Avenir" pitchFamily="34" charset="-122"/>
@@ -4194,8 +4248,8 @@
         </p:nvSpPr>
         <p:spPr>
           <a:xfrm>
-            <a:off x="411480" y="3749039"/>
-            <a:ext cx="8318500" cy="1302645"/>
+            <a:off x="5334000" y="990600"/>
+            <a:ext cx="3149600" cy="3556000"/>
           </a:xfrm>
           <a:prstGeom prst="rect">
             <a:avLst/>
@@ -4215,9 +4269,9 @@
               <a:buChar char="•"/>
             </a:pPr>
             <a:r>
-              <a:rPr lang="en-US" sz="800" dirty="0">
-                <a:solidFill>
-                  <a:srgbClr val="1A1A2E"/>
+              <a:rPr lang="en-US" sz="1000" dirty="0">
+                <a:solidFill>
+                  <a:srgbClr val="FFFFFF"/>
                 </a:solidFill>
                 <a:latin typeface="Avenir" pitchFamily="34" charset="0"/>
                 <a:ea typeface="Avenir" pitchFamily="34" charset="-122"/>
@@ -4225,7 +4279,7 @@
               </a:rPr>
               <a:t>{{DELIVERABLE_1}}</a:t>
             </a:r>
-            <a:endParaRPr lang="en-US" sz="800" dirty="0"/>
+            <a:endParaRPr lang="en-US" sz="1000" dirty="0"/>
           </a:p>
           <a:p>
             <a:pPr marL="342900" indent="-342900">
@@ -4236,9 +4290,9 @@
               <a:buChar char="•"/>
             </a:pPr>
             <a:r>
-              <a:rPr lang="en-US" sz="800" dirty="0">
-                <a:solidFill>
-                  <a:srgbClr val="1A1A2E"/>
+              <a:rPr lang="en-US" sz="1000" dirty="0">
+                <a:solidFill>
+                  <a:srgbClr val="FFFFFF"/>
                 </a:solidFill>
                 <a:latin typeface="Avenir" pitchFamily="34" charset="0"/>
                 <a:ea typeface="Avenir" pitchFamily="34" charset="-122"/>
@@ -4246,7 +4300,7 @@
               </a:rPr>
               <a:t>{{DELIVERABLE_2}}</a:t>
             </a:r>
-            <a:endParaRPr lang="en-US" sz="800" dirty="0"/>
+            <a:endParaRPr lang="en-US" sz="1000" dirty="0"/>
           </a:p>
           <a:p>
             <a:pPr marL="342900" indent="-342900">
@@ -4257,9 +4311,9 @@
               <a:buChar char="•"/>
             </a:pPr>
             <a:r>
-              <a:rPr lang="en-US" sz="800" dirty="0">
-                <a:solidFill>
-                  <a:srgbClr val="1A1A2E"/>
+              <a:rPr lang="en-US" sz="1000" dirty="0">
+                <a:solidFill>
+                  <a:srgbClr val="FFFFFF"/>
                 </a:solidFill>
                 <a:latin typeface="Avenir" pitchFamily="34" charset="0"/>
                 <a:ea typeface="Avenir" pitchFamily="34" charset="-122"/>
@@ -4267,14 +4321,14 @@
               </a:rPr>
               <a:t>{{DELIVERABLE_3}}</a:t>
             </a:r>
-            <a:endParaRPr lang="en-US" sz="800" dirty="0"/>
+            <a:endParaRPr lang="en-US" sz="1000" dirty="0"/>
           </a:p>
         </p:txBody>
       </p:sp>
     </p:spTree>
     <p:extLst>
       <p:ext uri="{BB962C8B-B14F-4D97-AF65-F5344CB8AC3E}">
-        <p14:creationId xmlns:p14="http://schemas.microsoft.com/office/powerpoint/2010/main" val="3757097027"/>
+        <p14:creationId xmlns:p14="http://schemas.microsoft.com/office/powerpoint/2010/main" val="1926256788"/>
       </p:ext>
     </p:extLst>
   </p:cSld>
@@ -4420,8 +4474,8 @@
         </p:nvSpPr>
         <p:spPr>
           <a:xfrm>
-            <a:off x="406400" y="952500"/>
-            <a:ext cx="8318500" cy="274320"/>
+            <a:off x="406400" y="889000"/>
+            <a:ext cx="2540000" cy="274320"/>
           </a:xfrm>
           <a:prstGeom prst="rect">
             <a:avLst/>
@@ -4459,8 +4513,8 @@
         </p:nvSpPr>
         <p:spPr>
           <a:xfrm>
-            <a:off x="406400" y="1188720"/>
-            <a:ext cx="8318500" cy="843280"/>
+            <a:off x="406400" y="1244600"/>
+            <a:ext cx="2540000" cy="381000"/>
           </a:xfrm>
           <a:prstGeom prst="rect">
             <a:avLst/>
@@ -4498,8 +4552,8 @@
         </p:nvSpPr>
         <p:spPr>
           <a:xfrm>
-            <a:off x="406400" y="2032000"/>
-            <a:ext cx="8318500" cy="274320"/>
+            <a:off x="3175000" y="889000"/>
+            <a:ext cx="2540000" cy="274320"/>
           </a:xfrm>
           <a:prstGeom prst="rect">
             <a:avLst/>
@@ -4537,8 +4591,8 @@
         </p:nvSpPr>
         <p:spPr>
           <a:xfrm>
-            <a:off x="406400" y="2306320"/>
-            <a:ext cx="8318500" cy="1117600"/>
+            <a:off x="3175000" y="1244600"/>
+            <a:ext cx="2540000" cy="381000"/>
           </a:xfrm>
           <a:prstGeom prst="rect">
             <a:avLst/>
@@ -4576,8 +4630,8 @@
         </p:nvSpPr>
         <p:spPr>
           <a:xfrm>
-            <a:off x="406400" y="3429000"/>
-            <a:ext cx="8318500" cy="274320"/>
+            <a:off x="5943600" y="889000"/>
+            <a:ext cx="2540000" cy="274320"/>
           </a:xfrm>
           <a:prstGeom prst="rect">
             <a:avLst/>
@@ -4615,8 +4669,8 @@
         </p:nvSpPr>
         <p:spPr>
           <a:xfrm>
-            <a:off x="406400" y="3708400"/>
-            <a:ext cx="8318500" cy="1117600"/>
+            <a:off x="5943600" y="1244600"/>
+            <a:ext cx="2540000" cy="381000"/>
           </a:xfrm>
           <a:prstGeom prst="rect">
             <a:avLst/>
@@ -4646,10 +4700,175 @@
           </a:p>
         </p:txBody>
       </p:sp>
+      <p:sp>
+        <p:nvSpPr>
+          <p:cNvPr id="6" name="TextBox 5">
+            <a:extLst>
+              <a:ext uri="{FF2B5EF4-FFF2-40B4-BE49-F238E27FC236}">
+                <a16:creationId xmlns:a16="http://schemas.microsoft.com/office/drawing/2014/main" id="{E25C1675-6D9A-EB4D-8408-5923250EAEAD}"/>
+              </a:ext>
+            </a:extLst>
+          </p:cNvPr>
+          <p:cNvSpPr txBox="1"/>
+          <p:nvPr/>
+        </p:nvSpPr>
+        <p:spPr>
+          <a:xfrm>
+            <a:off x="406400" y="1714499"/>
+            <a:ext cx="2540000" cy="3107757"/>
+          </a:xfrm>
+          <a:prstGeom prst="rect">
+            <a:avLst/>
+          </a:prstGeom>
+          <a:noFill/>
+        </p:spPr>
+        <p:txBody>
+          <a:bodyPr vertOverflow="overflow" vert="horz" wrap="square" rtlCol="0" anchor="t">
+            <a:noAutofit/>
+          </a:bodyPr>
+          <a:lstStyle/>
+          <a:p>
+            <a:pPr algn="l"/>
+            <a:r>
+              <a:rPr lang="en-US" sz="800" dirty="0">
+                <a:solidFill>
+                  <a:srgbClr val="CCCCCC"/>
+                </a:solidFill>
+                <a:latin typeface="Avenir"/>
+              </a:rPr>
+              <a:t>{{PLATFORM_1_DESC}}</a:t>
+            </a:r>
+          </a:p>
+        </p:txBody>
+      </p:sp>
+      <p:sp>
+        <p:nvSpPr>
+          <p:cNvPr id="7" name="TextBox 6">
+            <a:extLst>
+              <a:ext uri="{FF2B5EF4-FFF2-40B4-BE49-F238E27FC236}">
+                <a16:creationId xmlns:a16="http://schemas.microsoft.com/office/drawing/2014/main" id="{73AA8F1F-E517-AB4D-901C-ECCACA59A95E}"/>
+              </a:ext>
+            </a:extLst>
+          </p:cNvPr>
+          <p:cNvSpPr txBox="1"/>
+          <p:nvPr/>
+        </p:nvSpPr>
+        <p:spPr>
+          <a:xfrm>
+            <a:off x="3175000" y="1714500"/>
+            <a:ext cx="2540000" cy="3107756"/>
+          </a:xfrm>
+          <a:prstGeom prst="rect">
+            <a:avLst/>
+          </a:prstGeom>
+          <a:noFill/>
+        </p:spPr>
+        <p:txBody>
+          <a:bodyPr vertOverflow="overflow" vert="horz" wrap="square" rtlCol="0" anchor="t">
+            <a:noAutofit/>
+          </a:bodyPr>
+          <a:lstStyle/>
+          <a:p>
+            <a:pPr algn="l"/>
+            <a:r>
+              <a:rPr lang="en-US" sz="800" dirty="0">
+                <a:solidFill>
+                  <a:srgbClr val="CCCCCC"/>
+                </a:solidFill>
+                <a:latin typeface="Avenir"/>
+              </a:rPr>
+              <a:t>{{PLATFORM_2_DESC}}</a:t>
+            </a:r>
+          </a:p>
+        </p:txBody>
+      </p:sp>
+      <p:sp>
+        <p:nvSpPr>
+          <p:cNvPr id="8" name="TextBox 7">
+            <a:extLst>
+              <a:ext uri="{FF2B5EF4-FFF2-40B4-BE49-F238E27FC236}">
+                <a16:creationId xmlns:a16="http://schemas.microsoft.com/office/drawing/2014/main" id="{EF875415-EC62-CB4F-A058-91A9C6A389F1}"/>
+              </a:ext>
+            </a:extLst>
+          </p:cNvPr>
+          <p:cNvSpPr txBox="1"/>
+          <p:nvPr/>
+        </p:nvSpPr>
+        <p:spPr>
+          <a:xfrm>
+            <a:off x="5943600" y="1714500"/>
+            <a:ext cx="2540000" cy="3107756"/>
+          </a:xfrm>
+          <a:prstGeom prst="rect">
+            <a:avLst/>
+          </a:prstGeom>
+          <a:noFill/>
+        </p:spPr>
+        <p:txBody>
+          <a:bodyPr vertOverflow="overflow" vert="horz" wrap="square" rtlCol="0" anchor="t">
+            <a:noAutofit/>
+          </a:bodyPr>
+          <a:lstStyle/>
+          <a:p>
+            <a:pPr algn="l"/>
+            <a:r>
+              <a:rPr lang="en-US" sz="800" dirty="0">
+                <a:solidFill>
+                  <a:srgbClr val="CCCCCC"/>
+                </a:solidFill>
+                <a:latin typeface="Avenir"/>
+              </a:rPr>
+              <a:t>{{PLATFORM_3_DESC}}</a:t>
+            </a:r>
+          </a:p>
+        </p:txBody>
+      </p:sp>
+      <p:cxnSp>
+        <p:nvCxnSpPr>
+          <p:cNvPr id="50" name="Divider 1"/>
+          <p:cNvCxnSpPr/>
+          <p:nvPr/>
+        </p:nvCxnSpPr>
+        <p:spPr>
+          <a:xfrm>
+            <a:off x="3060700" y="889000"/>
+            <a:ext cx="0" cy="3810000"/>
+          </a:xfrm>
+          <a:prstGeom prst="line">
+            <a:avLst/>
+          </a:prstGeom>
+          <a:ln w="6350">
+            <a:solidFill>
+              <a:srgbClr val="3D3D5C"/>
+            </a:solidFill>
+          </a:ln>
+        </p:spPr>
+      </p:cxnSp>
+      <p:cxnSp>
+        <p:nvCxnSpPr>
+          <p:cNvPr id="51" name="Divider 2"/>
+          <p:cNvCxnSpPr/>
+          <p:nvPr/>
+        </p:nvCxnSpPr>
+        <p:spPr>
+          <a:xfrm>
+            <a:off x="5829300" y="889000"/>
+            <a:ext cx="0" cy="3810000"/>
+          </a:xfrm>
+          <a:prstGeom prst="line">
+            <a:avLst/>
+          </a:prstGeom>
+          <a:ln w="6350">
+            <a:solidFill>
+              <a:srgbClr val="3D3D5C"/>
+            </a:solidFill>
+          </a:ln>
+        </p:spPr>
+      </p:cxnSp>
     </p:spTree>
     <p:extLst>
       <p:ext uri="{BB962C8B-B14F-4D97-AF65-F5344CB8AC3E}">
-        <p14:creationId xmlns:p14="http://schemas.microsoft.com/office/powerpoint/2010/main" val="2336523692"/>
+        <p14:creationId xmlns:p14="http://schemas.microsoft.com/office/powerpoint/2010/main" val="3693473283"/>
       </p:ext>
     </p:extLst>
   </p:cSld>

</xml_diff>